<commit_message>
Consolidated insert: monthly P&L slide now exact model-format exhibit
Slide 2 replaced with a high-res render of the Combined 12-Mo P&L tab
itself (navy month bands, $/% pairs, full USAR taxonomy, parenthesized
negatives) so the slide matches the model's P&L summary formatting
exactly.

Co-Authored-By: Claude Fable 5 <noreply@anthropic.com>
Claude-Session: https://claude.ai/code/session_01VCQW3YoSqaJfwSKLPDyQy8
</commit_message>
<xml_diff>
--- a/Consolidated_Slides_Insert.pptx
+++ b/Consolidated_Slides_Insert.pptx
@@ -4214,7 +4214,7 @@
         </p:nvSpPr>
         <p:spPr>
           <a:xfrm>
-            <a:off x="950976" y="740664"/>
+            <a:off x="950976" y="457200"/>
             <a:ext cx="16459200" cy="320040"/>
           </a:xfrm>
           <a:prstGeom prst="rect">
@@ -4240,16 +4240,40 @@
           </a:p>
         </p:txBody>
       </p:sp>
-      <p:sp>
-        <p:nvSpPr>
-          <p:cNvPr id="3" name="TextBox 2"/>
+      <p:pic>
+        <p:nvPicPr>
+          <p:cNvPr id="3" name="Picture 2" descr="combined_pnl_exhibit.png"/>
+          <p:cNvPicPr>
+            <a:picLocks noChangeAspect="1"/>
+          </p:cNvPicPr>
+          <p:nvPr/>
+        </p:nvPicPr>
+        <p:blipFill>
+          <a:blip r:embed="rId2"/>
+          <a:stretch>
+            <a:fillRect/>
+          </a:stretch>
+        </p:blipFill>
+        <p:spPr>
+          <a:xfrm>
+            <a:off x="640079" y="960120"/>
+            <a:ext cx="17007840" cy="10117855"/>
+          </a:xfrm>
+          <a:prstGeom prst="rect">
+            <a:avLst/>
+          </a:prstGeom>
+        </p:spPr>
+      </p:pic>
+      <p:sp>
+        <p:nvSpPr>
+          <p:cNvPr id="4" name="TextBox 3"/>
           <p:cNvSpPr txBox="1"/>
           <p:nvPr/>
         </p:nvSpPr>
         <p:spPr>
           <a:xfrm>
-            <a:off x="950976" y="1106424"/>
-            <a:ext cx="16459200" cy="640080"/>
+            <a:off x="950976" y="11215135"/>
+            <a:ext cx="16367759" cy="365760"/>
           </a:xfrm>
           <a:prstGeom prst="rect">
             <a:avLst/>
@@ -4263,2669 +4287,13 @@
           <a:lstStyle/>
           <a:p>
             <a:r>
-              <a:rPr sz="4000">
-                <a:solidFill>
-                  <a:srgbClr val="22424B"/>
-                </a:solidFill>
-                <a:latin typeface="Georgia"/>
-              </a:rPr>
-              <a:t>The plan year, month by month</a:t>
-            </a:r>
-          </a:p>
-        </p:txBody>
-      </p:sp>
-      <p:graphicFrame>
-        <p:nvGraphicFramePr>
-          <p:cNvPr id="4" name="Table 3"/>
-          <p:cNvGraphicFramePr>
-            <a:graphicFrameLocks noGrp="1"/>
-          </p:cNvGraphicFramePr>
-          <p:nvPr/>
-        </p:nvGraphicFramePr>
-        <p:xfrm>
-          <a:off x="950976" y="2377440"/>
-          <a:ext cx="16367751" cy="4206240"/>
-        </p:xfrm>
-        <a:graphic>
-          <a:graphicData uri="http://schemas.openxmlformats.org/drawingml/2006/table">
-            <a:tbl>
-              <a:tblPr firstRow="1" bandRow="1">
-                <a:tableStyleId>{5C22544A-7EE6-4342-B048-85BDC9FD1C3A}</a:tableStyleId>
-              </a:tblPr>
-              <a:tblGrid>
-                <a:gridCol w="3108960"/>
-                <a:gridCol w="1019907"/>
-                <a:gridCol w="1019907"/>
-                <a:gridCol w="1019907"/>
-                <a:gridCol w="1019907"/>
-                <a:gridCol w="1019907"/>
-                <a:gridCol w="1019907"/>
-                <a:gridCol w="1019907"/>
-                <a:gridCol w="1019907"/>
-                <a:gridCol w="1019907"/>
-                <a:gridCol w="1019907"/>
-                <a:gridCol w="1019907"/>
-                <a:gridCol w="1019907"/>
-                <a:gridCol w="1019907"/>
-              </a:tblGrid>
-              <a:tr h="525780">
-                <a:tc>
-                  <a:txBody>
-                    <a:bodyPr/>
-                    <a:lstStyle/>
-                    <a:p>
-                      <a:r>
-                        <a:rPr sz="1100" b="1">
-                          <a:solidFill>
-                            <a:srgbClr val="FFFFFF"/>
-                          </a:solidFill>
-                          <a:latin typeface="Arial"/>
-                        </a:rPr>
-                        <a:t>$K</a:t>
-                      </a:r>
-                    </a:p>
-                  </a:txBody>
-                  <a:tcPr>
-                    <a:solidFill>
-                      <a:srgbClr val="22424B"/>
-                    </a:solidFill>
-                  </a:tcPr>
-                </a:tc>
-                <a:tc>
-                  <a:txBody>
-                    <a:bodyPr/>
-                    <a:lstStyle/>
-                    <a:p>
-                      <a:pPr algn="r"/>
-                      <a:r>
-                        <a:rPr sz="1100" b="1">
-                          <a:solidFill>
-                            <a:srgbClr val="FFFFFF"/>
-                          </a:solidFill>
-                          <a:latin typeface="Arial"/>
-                        </a:rPr>
-                        <a:t>JAN</a:t>
-                      </a:r>
-                    </a:p>
-                  </a:txBody>
-                  <a:tcPr>
-                    <a:solidFill>
-                      <a:srgbClr val="22424B"/>
-                    </a:solidFill>
-                  </a:tcPr>
-                </a:tc>
-                <a:tc>
-                  <a:txBody>
-                    <a:bodyPr/>
-                    <a:lstStyle/>
-                    <a:p>
-                      <a:pPr algn="r"/>
-                      <a:r>
-                        <a:rPr sz="1100" b="1">
-                          <a:solidFill>
-                            <a:srgbClr val="FFFFFF"/>
-                          </a:solidFill>
-                          <a:latin typeface="Arial"/>
-                        </a:rPr>
-                        <a:t>FEB</a:t>
-                      </a:r>
-                    </a:p>
-                  </a:txBody>
-                  <a:tcPr>
-                    <a:solidFill>
-                      <a:srgbClr val="22424B"/>
-                    </a:solidFill>
-                  </a:tcPr>
-                </a:tc>
-                <a:tc>
-                  <a:txBody>
-                    <a:bodyPr/>
-                    <a:lstStyle/>
-                    <a:p>
-                      <a:pPr algn="r"/>
-                      <a:r>
-                        <a:rPr sz="1100" b="1">
-                          <a:solidFill>
-                            <a:srgbClr val="FFFFFF"/>
-                          </a:solidFill>
-                          <a:latin typeface="Arial"/>
-                        </a:rPr>
-                        <a:t>MAR</a:t>
-                      </a:r>
-                    </a:p>
-                  </a:txBody>
-                  <a:tcPr>
-                    <a:solidFill>
-                      <a:srgbClr val="22424B"/>
-                    </a:solidFill>
-                  </a:tcPr>
-                </a:tc>
-                <a:tc>
-                  <a:txBody>
-                    <a:bodyPr/>
-                    <a:lstStyle/>
-                    <a:p>
-                      <a:pPr algn="r"/>
-                      <a:r>
-                        <a:rPr sz="1100" b="1">
-                          <a:solidFill>
-                            <a:srgbClr val="FFFFFF"/>
-                          </a:solidFill>
-                          <a:latin typeface="Arial"/>
-                        </a:rPr>
-                        <a:t>APR</a:t>
-                      </a:r>
-                    </a:p>
-                  </a:txBody>
-                  <a:tcPr>
-                    <a:solidFill>
-                      <a:srgbClr val="22424B"/>
-                    </a:solidFill>
-                  </a:tcPr>
-                </a:tc>
-                <a:tc>
-                  <a:txBody>
-                    <a:bodyPr/>
-                    <a:lstStyle/>
-                    <a:p>
-                      <a:pPr algn="r"/>
-                      <a:r>
-                        <a:rPr sz="1100" b="1">
-                          <a:solidFill>
-                            <a:srgbClr val="FFFFFF"/>
-                          </a:solidFill>
-                          <a:latin typeface="Arial"/>
-                        </a:rPr>
-                        <a:t>MAY</a:t>
-                      </a:r>
-                    </a:p>
-                  </a:txBody>
-                  <a:tcPr>
-                    <a:solidFill>
-                      <a:srgbClr val="22424B"/>
-                    </a:solidFill>
-                  </a:tcPr>
-                </a:tc>
-                <a:tc>
-                  <a:txBody>
-                    <a:bodyPr/>
-                    <a:lstStyle/>
-                    <a:p>
-                      <a:pPr algn="r"/>
-                      <a:r>
-                        <a:rPr sz="1100" b="1">
-                          <a:solidFill>
-                            <a:srgbClr val="FFFFFF"/>
-                          </a:solidFill>
-                          <a:latin typeface="Arial"/>
-                        </a:rPr>
-                        <a:t>JUN</a:t>
-                      </a:r>
-                    </a:p>
-                  </a:txBody>
-                  <a:tcPr>
-                    <a:solidFill>
-                      <a:srgbClr val="22424B"/>
-                    </a:solidFill>
-                  </a:tcPr>
-                </a:tc>
-                <a:tc>
-                  <a:txBody>
-                    <a:bodyPr/>
-                    <a:lstStyle/>
-                    <a:p>
-                      <a:pPr algn="r"/>
-                      <a:r>
-                        <a:rPr sz="1100" b="1">
-                          <a:solidFill>
-                            <a:srgbClr val="FFFFFF"/>
-                          </a:solidFill>
-                          <a:latin typeface="Arial"/>
-                        </a:rPr>
-                        <a:t>JUL</a:t>
-                      </a:r>
-                    </a:p>
-                  </a:txBody>
-                  <a:tcPr>
-                    <a:solidFill>
-                      <a:srgbClr val="22424B"/>
-                    </a:solidFill>
-                  </a:tcPr>
-                </a:tc>
-                <a:tc>
-                  <a:txBody>
-                    <a:bodyPr/>
-                    <a:lstStyle/>
-                    <a:p>
-                      <a:pPr algn="r"/>
-                      <a:r>
-                        <a:rPr sz="1100" b="1">
-                          <a:solidFill>
-                            <a:srgbClr val="FFFFFF"/>
-                          </a:solidFill>
-                          <a:latin typeface="Arial"/>
-                        </a:rPr>
-                        <a:t>AUG</a:t>
-                      </a:r>
-                    </a:p>
-                  </a:txBody>
-                  <a:tcPr>
-                    <a:solidFill>
-                      <a:srgbClr val="22424B"/>
-                    </a:solidFill>
-                  </a:tcPr>
-                </a:tc>
-                <a:tc>
-                  <a:txBody>
-                    <a:bodyPr/>
-                    <a:lstStyle/>
-                    <a:p>
-                      <a:pPr algn="r"/>
-                      <a:r>
-                        <a:rPr sz="1100" b="1">
-                          <a:solidFill>
-                            <a:srgbClr val="FFFFFF"/>
-                          </a:solidFill>
-                          <a:latin typeface="Arial"/>
-                        </a:rPr>
-                        <a:t>SEP</a:t>
-                      </a:r>
-                    </a:p>
-                  </a:txBody>
-                  <a:tcPr>
-                    <a:solidFill>
-                      <a:srgbClr val="22424B"/>
-                    </a:solidFill>
-                  </a:tcPr>
-                </a:tc>
-                <a:tc>
-                  <a:txBody>
-                    <a:bodyPr/>
-                    <a:lstStyle/>
-                    <a:p>
-                      <a:pPr algn="r"/>
-                      <a:r>
-                        <a:rPr sz="1100" b="1">
-                          <a:solidFill>
-                            <a:srgbClr val="FFFFFF"/>
-                          </a:solidFill>
-                          <a:latin typeface="Arial"/>
-                        </a:rPr>
-                        <a:t>OCT</a:t>
-                      </a:r>
-                    </a:p>
-                  </a:txBody>
-                  <a:tcPr>
-                    <a:solidFill>
-                      <a:srgbClr val="22424B"/>
-                    </a:solidFill>
-                  </a:tcPr>
-                </a:tc>
-                <a:tc>
-                  <a:txBody>
-                    <a:bodyPr/>
-                    <a:lstStyle/>
-                    <a:p>
-                      <a:pPr algn="r"/>
-                      <a:r>
-                        <a:rPr sz="1100" b="1">
-                          <a:solidFill>
-                            <a:srgbClr val="FFFFFF"/>
-                          </a:solidFill>
-                          <a:latin typeface="Arial"/>
-                        </a:rPr>
-                        <a:t>NOV</a:t>
-                      </a:r>
-                    </a:p>
-                  </a:txBody>
-                  <a:tcPr>
-                    <a:solidFill>
-                      <a:srgbClr val="22424B"/>
-                    </a:solidFill>
-                  </a:tcPr>
-                </a:tc>
-                <a:tc>
-                  <a:txBody>
-                    <a:bodyPr/>
-                    <a:lstStyle/>
-                    <a:p>
-                      <a:pPr algn="r"/>
-                      <a:r>
-                        <a:rPr sz="1100" b="1">
-                          <a:solidFill>
-                            <a:srgbClr val="FFFFFF"/>
-                          </a:solidFill>
-                          <a:latin typeface="Arial"/>
-                        </a:rPr>
-                        <a:t>DEC</a:t>
-                      </a:r>
-                    </a:p>
-                  </a:txBody>
-                  <a:tcPr>
-                    <a:solidFill>
-                      <a:srgbClr val="22424B"/>
-                    </a:solidFill>
-                  </a:tcPr>
-                </a:tc>
-                <a:tc>
-                  <a:txBody>
-                    <a:bodyPr/>
-                    <a:lstStyle/>
-                    <a:p>
-                      <a:pPr algn="r"/>
-                      <a:r>
-                        <a:rPr sz="1100" b="1">
-                          <a:solidFill>
-                            <a:srgbClr val="FFFFFF"/>
-                          </a:solidFill>
-                          <a:latin typeface="Arial"/>
-                        </a:rPr>
-                        <a:t>FY 2027</a:t>
-                      </a:r>
-                    </a:p>
-                  </a:txBody>
-                  <a:tcPr>
-                    <a:solidFill>
-                      <a:srgbClr val="22424B"/>
-                    </a:solidFill>
-                  </a:tcPr>
-                </a:tc>
-              </a:tr>
-              <a:tr h="525780">
-                <a:tc>
-                  <a:txBody>
-                    <a:bodyPr/>
-                    <a:lstStyle/>
-                    <a:p>
-                      <a:r>
-                        <a:rPr sz="1300">
-                          <a:solidFill>
-                            <a:srgbClr val="3F4A4E"/>
-                          </a:solidFill>
-                          <a:latin typeface="Arial"/>
-                        </a:rPr>
-                        <a:t>Total income</a:t>
-                      </a:r>
-                    </a:p>
-                  </a:txBody>
-                  <a:tcPr>
-                    <a:solidFill>
-                      <a:srgbClr val="F7F6F2"/>
-                    </a:solidFill>
-                  </a:tcPr>
-                </a:tc>
-                <a:tc>
-                  <a:txBody>
-                    <a:bodyPr/>
-                    <a:lstStyle/>
-                    <a:p>
-                      <a:pPr algn="r"/>
-                      <a:r>
-                        <a:rPr sz="1300">
-                          <a:solidFill>
-                            <a:srgbClr val="3F4A4E"/>
-                          </a:solidFill>
-                          <a:latin typeface="Arial"/>
-                        </a:rPr>
-                        <a:t>80.2</a:t>
-                      </a:r>
-                    </a:p>
-                  </a:txBody>
-                  <a:tcPr>
-                    <a:solidFill>
-                      <a:srgbClr val="F7F6F2"/>
-                    </a:solidFill>
-                  </a:tcPr>
-                </a:tc>
-                <a:tc>
-                  <a:txBody>
-                    <a:bodyPr/>
-                    <a:lstStyle/>
-                    <a:p>
-                      <a:pPr algn="r"/>
-                      <a:r>
-                        <a:rPr sz="1300">
-                          <a:solidFill>
-                            <a:srgbClr val="3F4A4E"/>
-                          </a:solidFill>
-                          <a:latin typeface="Arial"/>
-                        </a:rPr>
-                        <a:t>45.2</a:t>
-                      </a:r>
-                    </a:p>
-                  </a:txBody>
-                  <a:tcPr>
-                    <a:solidFill>
-                      <a:srgbClr val="F7F6F2"/>
-                    </a:solidFill>
-                  </a:tcPr>
-                </a:tc>
-                <a:tc>
-                  <a:txBody>
-                    <a:bodyPr/>
-                    <a:lstStyle/>
-                    <a:p>
-                      <a:pPr algn="r"/>
-                      <a:r>
-                        <a:rPr sz="1300">
-                          <a:solidFill>
-                            <a:srgbClr val="3F4A4E"/>
-                          </a:solidFill>
-                          <a:latin typeface="Arial"/>
-                        </a:rPr>
-                        <a:t>80.2</a:t>
-                      </a:r>
-                    </a:p>
-                  </a:txBody>
-                  <a:tcPr>
-                    <a:solidFill>
-                      <a:srgbClr val="F7F6F2"/>
-                    </a:solidFill>
-                  </a:tcPr>
-                </a:tc>
-                <a:tc>
-                  <a:txBody>
-                    <a:bodyPr/>
-                    <a:lstStyle/>
-                    <a:p>
-                      <a:pPr algn="r"/>
-                      <a:r>
-                        <a:rPr sz="1300">
-                          <a:solidFill>
-                            <a:srgbClr val="3F4A4E"/>
-                          </a:solidFill>
-                          <a:latin typeface="Arial"/>
-                        </a:rPr>
-                        <a:t>45.2</a:t>
-                      </a:r>
-                    </a:p>
-                  </a:txBody>
-                  <a:tcPr>
-                    <a:solidFill>
-                      <a:srgbClr val="F7F6F2"/>
-                    </a:solidFill>
-                  </a:tcPr>
-                </a:tc>
-                <a:tc>
-                  <a:txBody>
-                    <a:bodyPr/>
-                    <a:lstStyle/>
-                    <a:p>
-                      <a:pPr algn="r"/>
-                      <a:r>
-                        <a:rPr sz="1300">
-                          <a:solidFill>
-                            <a:srgbClr val="3F4A4E"/>
-                          </a:solidFill>
-                          <a:latin typeface="Arial"/>
-                        </a:rPr>
-                        <a:t>70.2</a:t>
-                      </a:r>
-                    </a:p>
-                  </a:txBody>
-                  <a:tcPr>
-                    <a:solidFill>
-                      <a:srgbClr val="F7F6F2"/>
-                    </a:solidFill>
-                  </a:tcPr>
-                </a:tc>
-                <a:tc>
-                  <a:txBody>
-                    <a:bodyPr/>
-                    <a:lstStyle/>
-                    <a:p>
-                      <a:pPr algn="r"/>
-                      <a:r>
-                        <a:rPr sz="1300">
-                          <a:solidFill>
-                            <a:srgbClr val="3F4A4E"/>
-                          </a:solidFill>
-                          <a:latin typeface="Arial"/>
-                        </a:rPr>
-                        <a:t>65.2</a:t>
-                      </a:r>
-                    </a:p>
-                  </a:txBody>
-                  <a:tcPr>
-                    <a:solidFill>
-                      <a:srgbClr val="F7F6F2"/>
-                    </a:solidFill>
-                  </a:tcPr>
-                </a:tc>
-                <a:tc>
-                  <a:txBody>
-                    <a:bodyPr/>
-                    <a:lstStyle/>
-                    <a:p>
-                      <a:pPr algn="r"/>
-                      <a:r>
-                        <a:rPr sz="1300">
-                          <a:solidFill>
-                            <a:srgbClr val="3F4A4E"/>
-                          </a:solidFill>
-                          <a:latin typeface="Arial"/>
-                        </a:rPr>
-                        <a:t>65.2</a:t>
-                      </a:r>
-                    </a:p>
-                  </a:txBody>
-                  <a:tcPr>
-                    <a:solidFill>
-                      <a:srgbClr val="F7F6F2"/>
-                    </a:solidFill>
-                  </a:tcPr>
-                </a:tc>
-                <a:tc>
-                  <a:txBody>
-                    <a:bodyPr/>
-                    <a:lstStyle/>
-                    <a:p>
-                      <a:pPr algn="r"/>
-                      <a:r>
-                        <a:rPr sz="1300">
-                          <a:solidFill>
-                            <a:srgbClr val="3F4A4E"/>
-                          </a:solidFill>
-                          <a:latin typeface="Arial"/>
-                        </a:rPr>
-                        <a:t>65.2</a:t>
-                      </a:r>
-                    </a:p>
-                  </a:txBody>
-                  <a:tcPr>
-                    <a:solidFill>
-                      <a:srgbClr val="F7F6F2"/>
-                    </a:solidFill>
-                  </a:tcPr>
-                </a:tc>
-                <a:tc>
-                  <a:txBody>
-                    <a:bodyPr/>
-                    <a:lstStyle/>
-                    <a:p>
-                      <a:pPr algn="r"/>
-                      <a:r>
-                        <a:rPr sz="1300">
-                          <a:solidFill>
-                            <a:srgbClr val="3F4A4E"/>
-                          </a:solidFill>
-                          <a:latin typeface="Arial"/>
-                        </a:rPr>
-                        <a:t>65.2</a:t>
-                      </a:r>
-                    </a:p>
-                  </a:txBody>
-                  <a:tcPr>
-                    <a:solidFill>
-                      <a:srgbClr val="F7F6F2"/>
-                    </a:solidFill>
-                  </a:tcPr>
-                </a:tc>
-                <a:tc>
-                  <a:txBody>
-                    <a:bodyPr/>
-                    <a:lstStyle/>
-                    <a:p>
-                      <a:pPr algn="r"/>
-                      <a:r>
-                        <a:rPr sz="1300">
-                          <a:solidFill>
-                            <a:srgbClr val="3F4A4E"/>
-                          </a:solidFill>
-                          <a:latin typeface="Arial"/>
-                        </a:rPr>
-                        <a:t>65.2</a:t>
-                      </a:r>
-                    </a:p>
-                  </a:txBody>
-                  <a:tcPr>
-                    <a:solidFill>
-                      <a:srgbClr val="F7F6F2"/>
-                    </a:solidFill>
-                  </a:tcPr>
-                </a:tc>
-                <a:tc>
-                  <a:txBody>
-                    <a:bodyPr/>
-                    <a:lstStyle/>
-                    <a:p>
-                      <a:pPr algn="r"/>
-                      <a:r>
-                        <a:rPr sz="1300">
-                          <a:solidFill>
-                            <a:srgbClr val="3F4A4E"/>
-                          </a:solidFill>
-                          <a:latin typeface="Arial"/>
-                        </a:rPr>
-                        <a:t>65.2</a:t>
-                      </a:r>
-                    </a:p>
-                  </a:txBody>
-                  <a:tcPr>
-                    <a:solidFill>
-                      <a:srgbClr val="F7F6F2"/>
-                    </a:solidFill>
-                  </a:tcPr>
-                </a:tc>
-                <a:tc>
-                  <a:txBody>
-                    <a:bodyPr/>
-                    <a:lstStyle/>
-                    <a:p>
-                      <a:pPr algn="r"/>
-                      <a:r>
-                        <a:rPr sz="1300">
-                          <a:solidFill>
-                            <a:srgbClr val="3F4A4E"/>
-                          </a:solidFill>
-                          <a:latin typeface="Arial"/>
-                        </a:rPr>
-                        <a:t>65.2</a:t>
-                      </a:r>
-                    </a:p>
-                  </a:txBody>
-                  <a:tcPr>
-                    <a:solidFill>
-                      <a:srgbClr val="F7F6F2"/>
-                    </a:solidFill>
-                  </a:tcPr>
-                </a:tc>
-                <a:tc>
-                  <a:txBody>
-                    <a:bodyPr/>
-                    <a:lstStyle/>
-                    <a:p>
-                      <a:pPr algn="r"/>
-                      <a:r>
-                        <a:rPr sz="1300">
-                          <a:solidFill>
-                            <a:srgbClr val="3F4A4E"/>
-                          </a:solidFill>
-                          <a:latin typeface="Arial"/>
-                        </a:rPr>
-                        <a:t>777.1</a:t>
-                      </a:r>
-                    </a:p>
-                  </a:txBody>
-                  <a:tcPr>
-                    <a:solidFill>
-                      <a:srgbClr val="F7F6F2"/>
-                    </a:solidFill>
-                  </a:tcPr>
-                </a:tc>
-              </a:tr>
-              <a:tr h="525780">
-                <a:tc>
-                  <a:txBody>
-                    <a:bodyPr/>
-                    <a:lstStyle/>
-                    <a:p>
-                      <a:r>
-                        <a:rPr sz="1300">
-                          <a:solidFill>
-                            <a:srgbClr val="3F4A4E"/>
-                          </a:solidFill>
-                          <a:latin typeface="Arial"/>
-                        </a:rPr>
-                        <a:t>Cost of goods sold</a:t>
-                      </a:r>
-                    </a:p>
-                  </a:txBody>
-                  <a:tcPr>
-                    <a:solidFill>
-                      <a:srgbClr val="FFFFFF"/>
-                    </a:solidFill>
-                  </a:tcPr>
-                </a:tc>
-                <a:tc>
-                  <a:txBody>
-                    <a:bodyPr/>
-                    <a:lstStyle/>
-                    <a:p>
-                      <a:pPr algn="r"/>
-                      <a:r>
-                        <a:rPr sz="1300">
-                          <a:solidFill>
-                            <a:srgbClr val="3F4A4E"/>
-                          </a:solidFill>
-                          <a:latin typeface="Arial"/>
-                        </a:rPr>
-                        <a:t>31.7</a:t>
-                      </a:r>
-                    </a:p>
-                  </a:txBody>
-                  <a:tcPr>
-                    <a:solidFill>
-                      <a:srgbClr val="FFFFFF"/>
-                    </a:solidFill>
-                  </a:tcPr>
-                </a:tc>
-                <a:tc>
-                  <a:txBody>
-                    <a:bodyPr/>
-                    <a:lstStyle/>
-                    <a:p>
-                      <a:pPr algn="r"/>
-                      <a:r>
-                        <a:rPr sz="1300">
-                          <a:solidFill>
-                            <a:srgbClr val="3F4A4E"/>
-                          </a:solidFill>
-                          <a:latin typeface="Arial"/>
-                        </a:rPr>
-                        <a:t>17.3</a:t>
-                      </a:r>
-                    </a:p>
-                  </a:txBody>
-                  <a:tcPr>
-                    <a:solidFill>
-                      <a:srgbClr val="FFFFFF"/>
-                    </a:solidFill>
-                  </a:tcPr>
-                </a:tc>
-                <a:tc>
-                  <a:txBody>
-                    <a:bodyPr/>
-                    <a:lstStyle/>
-                    <a:p>
-                      <a:pPr algn="r"/>
-                      <a:r>
-                        <a:rPr sz="1300">
-                          <a:solidFill>
-                            <a:srgbClr val="3F4A4E"/>
-                          </a:solidFill>
-                          <a:latin typeface="Arial"/>
-                        </a:rPr>
-                        <a:t>31.7</a:t>
-                      </a:r>
-                    </a:p>
-                  </a:txBody>
-                  <a:tcPr>
-                    <a:solidFill>
-                      <a:srgbClr val="FFFFFF"/>
-                    </a:solidFill>
-                  </a:tcPr>
-                </a:tc>
-                <a:tc>
-                  <a:txBody>
-                    <a:bodyPr/>
-                    <a:lstStyle/>
-                    <a:p>
-                      <a:pPr algn="r"/>
-                      <a:r>
-                        <a:rPr sz="1300">
-                          <a:solidFill>
-                            <a:srgbClr val="3F4A4E"/>
-                          </a:solidFill>
-                          <a:latin typeface="Arial"/>
-                        </a:rPr>
-                        <a:t>17.3</a:t>
-                      </a:r>
-                    </a:p>
-                  </a:txBody>
-                  <a:tcPr>
-                    <a:solidFill>
-                      <a:srgbClr val="FFFFFF"/>
-                    </a:solidFill>
-                  </a:tcPr>
-                </a:tc>
-                <a:tc>
-                  <a:txBody>
-                    <a:bodyPr/>
-                    <a:lstStyle/>
-                    <a:p>
-                      <a:pPr algn="r"/>
-                      <a:r>
-                        <a:rPr sz="1300">
-                          <a:solidFill>
-                            <a:srgbClr val="3F4A4E"/>
-                          </a:solidFill>
-                          <a:latin typeface="Arial"/>
-                        </a:rPr>
-                        <a:t>27.6</a:t>
-                      </a:r>
-                    </a:p>
-                  </a:txBody>
-                  <a:tcPr>
-                    <a:solidFill>
-                      <a:srgbClr val="FFFFFF"/>
-                    </a:solidFill>
-                  </a:tcPr>
-                </a:tc>
-                <a:tc>
-                  <a:txBody>
-                    <a:bodyPr/>
-                    <a:lstStyle/>
-                    <a:p>
-                      <a:pPr algn="r"/>
-                      <a:r>
-                        <a:rPr sz="1300">
-                          <a:solidFill>
-                            <a:srgbClr val="3F4A4E"/>
-                          </a:solidFill>
-                          <a:latin typeface="Arial"/>
-                        </a:rPr>
-                        <a:t>25.5</a:t>
-                      </a:r>
-                    </a:p>
-                  </a:txBody>
-                  <a:tcPr>
-                    <a:solidFill>
-                      <a:srgbClr val="FFFFFF"/>
-                    </a:solidFill>
-                  </a:tcPr>
-                </a:tc>
-                <a:tc>
-                  <a:txBody>
-                    <a:bodyPr/>
-                    <a:lstStyle/>
-                    <a:p>
-                      <a:pPr algn="r"/>
-                      <a:r>
-                        <a:rPr sz="1300">
-                          <a:solidFill>
-                            <a:srgbClr val="3F4A4E"/>
-                          </a:solidFill>
-                          <a:latin typeface="Arial"/>
-                        </a:rPr>
-                        <a:t>25.5</a:t>
-                      </a:r>
-                    </a:p>
-                  </a:txBody>
-                  <a:tcPr>
-                    <a:solidFill>
-                      <a:srgbClr val="FFFFFF"/>
-                    </a:solidFill>
-                  </a:tcPr>
-                </a:tc>
-                <a:tc>
-                  <a:txBody>
-                    <a:bodyPr/>
-                    <a:lstStyle/>
-                    <a:p>
-                      <a:pPr algn="r"/>
-                      <a:r>
-                        <a:rPr sz="1300">
-                          <a:solidFill>
-                            <a:srgbClr val="3F4A4E"/>
-                          </a:solidFill>
-                          <a:latin typeface="Arial"/>
-                        </a:rPr>
-                        <a:t>25.5</a:t>
-                      </a:r>
-                    </a:p>
-                  </a:txBody>
-                  <a:tcPr>
-                    <a:solidFill>
-                      <a:srgbClr val="FFFFFF"/>
-                    </a:solidFill>
-                  </a:tcPr>
-                </a:tc>
-                <a:tc>
-                  <a:txBody>
-                    <a:bodyPr/>
-                    <a:lstStyle/>
-                    <a:p>
-                      <a:pPr algn="r"/>
-                      <a:r>
-                        <a:rPr sz="1300">
-                          <a:solidFill>
-                            <a:srgbClr val="3F4A4E"/>
-                          </a:solidFill>
-                          <a:latin typeface="Arial"/>
-                        </a:rPr>
-                        <a:t>25.5</a:t>
-                      </a:r>
-                    </a:p>
-                  </a:txBody>
-                  <a:tcPr>
-                    <a:solidFill>
-                      <a:srgbClr val="FFFFFF"/>
-                    </a:solidFill>
-                  </a:tcPr>
-                </a:tc>
-                <a:tc>
-                  <a:txBody>
-                    <a:bodyPr/>
-                    <a:lstStyle/>
-                    <a:p>
-                      <a:pPr algn="r"/>
-                      <a:r>
-                        <a:rPr sz="1300">
-                          <a:solidFill>
-                            <a:srgbClr val="3F4A4E"/>
-                          </a:solidFill>
-                          <a:latin typeface="Arial"/>
-                        </a:rPr>
-                        <a:t>25.5</a:t>
-                      </a:r>
-                    </a:p>
-                  </a:txBody>
-                  <a:tcPr>
-                    <a:solidFill>
-                      <a:srgbClr val="FFFFFF"/>
-                    </a:solidFill>
-                  </a:tcPr>
-                </a:tc>
-                <a:tc>
-                  <a:txBody>
-                    <a:bodyPr/>
-                    <a:lstStyle/>
-                    <a:p>
-                      <a:pPr algn="r"/>
-                      <a:r>
-                        <a:rPr sz="1300">
-                          <a:solidFill>
-                            <a:srgbClr val="3F4A4E"/>
-                          </a:solidFill>
-                          <a:latin typeface="Arial"/>
-                        </a:rPr>
-                        <a:t>25.5</a:t>
-                      </a:r>
-                    </a:p>
-                  </a:txBody>
-                  <a:tcPr>
-                    <a:solidFill>
-                      <a:srgbClr val="FFFFFF"/>
-                    </a:solidFill>
-                  </a:tcPr>
-                </a:tc>
-                <a:tc>
-                  <a:txBody>
-                    <a:bodyPr/>
-                    <a:lstStyle/>
-                    <a:p>
-                      <a:pPr algn="r"/>
-                      <a:r>
-                        <a:rPr sz="1300">
-                          <a:solidFill>
-                            <a:srgbClr val="3F4A4E"/>
-                          </a:solidFill>
-                          <a:latin typeface="Arial"/>
-                        </a:rPr>
-                        <a:t>25.5</a:t>
-                      </a:r>
-                    </a:p>
-                  </a:txBody>
-                  <a:tcPr>
-                    <a:solidFill>
-                      <a:srgbClr val="FFFFFF"/>
-                    </a:solidFill>
-                  </a:tcPr>
-                </a:tc>
-                <a:tc>
-                  <a:txBody>
-                    <a:bodyPr/>
-                    <a:lstStyle/>
-                    <a:p>
-                      <a:pPr algn="r"/>
-                      <a:r>
-                        <a:rPr sz="1300">
-                          <a:solidFill>
-                            <a:srgbClr val="3F4A4E"/>
-                          </a:solidFill>
-                          <a:latin typeface="Arial"/>
-                        </a:rPr>
-                        <a:t>304.4</a:t>
-                      </a:r>
-                    </a:p>
-                  </a:txBody>
-                  <a:tcPr>
-                    <a:solidFill>
-                      <a:srgbClr val="FFFFFF"/>
-                    </a:solidFill>
-                  </a:tcPr>
-                </a:tc>
-              </a:tr>
-              <a:tr h="525780">
-                <a:tc>
-                  <a:txBody>
-                    <a:bodyPr/>
-                    <a:lstStyle/>
-                    <a:p>
-                      <a:r>
-                        <a:rPr sz="1300">
-                          <a:solidFill>
-                            <a:srgbClr val="3F4A4E"/>
-                          </a:solidFill>
-                          <a:latin typeface="Arial"/>
-                        </a:rPr>
-                        <a:t>Gross profit</a:t>
-                      </a:r>
-                    </a:p>
-                  </a:txBody>
-                  <a:tcPr>
-                    <a:solidFill>
-                      <a:srgbClr val="F7F6F2"/>
-                    </a:solidFill>
-                  </a:tcPr>
-                </a:tc>
-                <a:tc>
-                  <a:txBody>
-                    <a:bodyPr/>
-                    <a:lstStyle/>
-                    <a:p>
-                      <a:pPr algn="r"/>
-                      <a:r>
-                        <a:rPr sz="1300">
-                          <a:solidFill>
-                            <a:srgbClr val="3F4A4E"/>
-                          </a:solidFill>
-                          <a:latin typeface="Arial"/>
-                        </a:rPr>
-                        <a:t>48.5</a:t>
-                      </a:r>
-                    </a:p>
-                  </a:txBody>
-                  <a:tcPr>
-                    <a:solidFill>
-                      <a:srgbClr val="F7F6F2"/>
-                    </a:solidFill>
-                  </a:tcPr>
-                </a:tc>
-                <a:tc>
-                  <a:txBody>
-                    <a:bodyPr/>
-                    <a:lstStyle/>
-                    <a:p>
-                      <a:pPr algn="r"/>
-                      <a:r>
-                        <a:rPr sz="1300">
-                          <a:solidFill>
-                            <a:srgbClr val="3F4A4E"/>
-                          </a:solidFill>
-                          <a:latin typeface="Arial"/>
-                        </a:rPr>
-                        <a:t>27.8</a:t>
-                      </a:r>
-                    </a:p>
-                  </a:txBody>
-                  <a:tcPr>
-                    <a:solidFill>
-                      <a:srgbClr val="F7F6F2"/>
-                    </a:solidFill>
-                  </a:tcPr>
-                </a:tc>
-                <a:tc>
-                  <a:txBody>
-                    <a:bodyPr/>
-                    <a:lstStyle/>
-                    <a:p>
-                      <a:pPr algn="r"/>
-                      <a:r>
-                        <a:rPr sz="1300">
-                          <a:solidFill>
-                            <a:srgbClr val="3F4A4E"/>
-                          </a:solidFill>
-                          <a:latin typeface="Arial"/>
-                        </a:rPr>
-                        <a:t>48.5</a:t>
-                      </a:r>
-                    </a:p>
-                  </a:txBody>
-                  <a:tcPr>
-                    <a:solidFill>
-                      <a:srgbClr val="F7F6F2"/>
-                    </a:solidFill>
-                  </a:tcPr>
-                </a:tc>
-                <a:tc>
-                  <a:txBody>
-                    <a:bodyPr/>
-                    <a:lstStyle/>
-                    <a:p>
-                      <a:pPr algn="r"/>
-                      <a:r>
-                        <a:rPr sz="1300">
-                          <a:solidFill>
-                            <a:srgbClr val="3F4A4E"/>
-                          </a:solidFill>
-                          <a:latin typeface="Arial"/>
-                        </a:rPr>
-                        <a:t>27.8</a:t>
-                      </a:r>
-                    </a:p>
-                  </a:txBody>
-                  <a:tcPr>
-                    <a:solidFill>
-                      <a:srgbClr val="F7F6F2"/>
-                    </a:solidFill>
-                  </a:tcPr>
-                </a:tc>
-                <a:tc>
-                  <a:txBody>
-                    <a:bodyPr/>
-                    <a:lstStyle/>
-                    <a:p>
-                      <a:pPr algn="r"/>
-                      <a:r>
-                        <a:rPr sz="1300">
-                          <a:solidFill>
-                            <a:srgbClr val="3F4A4E"/>
-                          </a:solidFill>
-                          <a:latin typeface="Arial"/>
-                        </a:rPr>
-                        <a:t>42.6</a:t>
-                      </a:r>
-                    </a:p>
-                  </a:txBody>
-                  <a:tcPr>
-                    <a:solidFill>
-                      <a:srgbClr val="F7F6F2"/>
-                    </a:solidFill>
-                  </a:tcPr>
-                </a:tc>
-                <a:tc>
-                  <a:txBody>
-                    <a:bodyPr/>
-                    <a:lstStyle/>
-                    <a:p>
-                      <a:pPr algn="r"/>
-                      <a:r>
-                        <a:rPr sz="1300">
-                          <a:solidFill>
-                            <a:srgbClr val="3F4A4E"/>
-                          </a:solidFill>
-                          <a:latin typeface="Arial"/>
-                        </a:rPr>
-                        <a:t>39.6</a:t>
-                      </a:r>
-                    </a:p>
-                  </a:txBody>
-                  <a:tcPr>
-                    <a:solidFill>
-                      <a:srgbClr val="F7F6F2"/>
-                    </a:solidFill>
-                  </a:tcPr>
-                </a:tc>
-                <a:tc>
-                  <a:txBody>
-                    <a:bodyPr/>
-                    <a:lstStyle/>
-                    <a:p>
-                      <a:pPr algn="r"/>
-                      <a:r>
-                        <a:rPr sz="1300">
-                          <a:solidFill>
-                            <a:srgbClr val="3F4A4E"/>
-                          </a:solidFill>
-                          <a:latin typeface="Arial"/>
-                        </a:rPr>
-                        <a:t>39.6</a:t>
-                      </a:r>
-                    </a:p>
-                  </a:txBody>
-                  <a:tcPr>
-                    <a:solidFill>
-                      <a:srgbClr val="F7F6F2"/>
-                    </a:solidFill>
-                  </a:tcPr>
-                </a:tc>
-                <a:tc>
-                  <a:txBody>
-                    <a:bodyPr/>
-                    <a:lstStyle/>
-                    <a:p>
-                      <a:pPr algn="r"/>
-                      <a:r>
-                        <a:rPr sz="1300">
-                          <a:solidFill>
-                            <a:srgbClr val="3F4A4E"/>
-                          </a:solidFill>
-                          <a:latin typeface="Arial"/>
-                        </a:rPr>
-                        <a:t>39.6</a:t>
-                      </a:r>
-                    </a:p>
-                  </a:txBody>
-                  <a:tcPr>
-                    <a:solidFill>
-                      <a:srgbClr val="F7F6F2"/>
-                    </a:solidFill>
-                  </a:tcPr>
-                </a:tc>
-                <a:tc>
-                  <a:txBody>
-                    <a:bodyPr/>
-                    <a:lstStyle/>
-                    <a:p>
-                      <a:pPr algn="r"/>
-                      <a:r>
-                        <a:rPr sz="1300">
-                          <a:solidFill>
-                            <a:srgbClr val="3F4A4E"/>
-                          </a:solidFill>
-                          <a:latin typeface="Arial"/>
-                        </a:rPr>
-                        <a:t>39.6</a:t>
-                      </a:r>
-                    </a:p>
-                  </a:txBody>
-                  <a:tcPr>
-                    <a:solidFill>
-                      <a:srgbClr val="F7F6F2"/>
-                    </a:solidFill>
-                  </a:tcPr>
-                </a:tc>
-                <a:tc>
-                  <a:txBody>
-                    <a:bodyPr/>
-                    <a:lstStyle/>
-                    <a:p>
-                      <a:pPr algn="r"/>
-                      <a:r>
-                        <a:rPr sz="1300">
-                          <a:solidFill>
-                            <a:srgbClr val="3F4A4E"/>
-                          </a:solidFill>
-                          <a:latin typeface="Arial"/>
-                        </a:rPr>
-                        <a:t>39.6</a:t>
-                      </a:r>
-                    </a:p>
-                  </a:txBody>
-                  <a:tcPr>
-                    <a:solidFill>
-                      <a:srgbClr val="F7F6F2"/>
-                    </a:solidFill>
-                  </a:tcPr>
-                </a:tc>
-                <a:tc>
-                  <a:txBody>
-                    <a:bodyPr/>
-                    <a:lstStyle/>
-                    <a:p>
-                      <a:pPr algn="r"/>
-                      <a:r>
-                        <a:rPr sz="1300">
-                          <a:solidFill>
-                            <a:srgbClr val="3F4A4E"/>
-                          </a:solidFill>
-                          <a:latin typeface="Arial"/>
-                        </a:rPr>
-                        <a:t>39.6</a:t>
-                      </a:r>
-                    </a:p>
-                  </a:txBody>
-                  <a:tcPr>
-                    <a:solidFill>
-                      <a:srgbClr val="F7F6F2"/>
-                    </a:solidFill>
-                  </a:tcPr>
-                </a:tc>
-                <a:tc>
-                  <a:txBody>
-                    <a:bodyPr/>
-                    <a:lstStyle/>
-                    <a:p>
-                      <a:pPr algn="r"/>
-                      <a:r>
-                        <a:rPr sz="1300">
-                          <a:solidFill>
-                            <a:srgbClr val="3F4A4E"/>
-                          </a:solidFill>
-                          <a:latin typeface="Arial"/>
-                        </a:rPr>
-                        <a:t>39.6</a:t>
-                      </a:r>
-                    </a:p>
-                  </a:txBody>
-                  <a:tcPr>
-                    <a:solidFill>
-                      <a:srgbClr val="F7F6F2"/>
-                    </a:solidFill>
-                  </a:tcPr>
-                </a:tc>
-                <a:tc>
-                  <a:txBody>
-                    <a:bodyPr/>
-                    <a:lstStyle/>
-                    <a:p>
-                      <a:pPr algn="r"/>
-                      <a:r>
-                        <a:rPr sz="1300">
-                          <a:solidFill>
-                            <a:srgbClr val="3F4A4E"/>
-                          </a:solidFill>
-                          <a:latin typeface="Arial"/>
-                        </a:rPr>
-                        <a:t>472.7</a:t>
-                      </a:r>
-                    </a:p>
-                  </a:txBody>
-                  <a:tcPr>
-                    <a:solidFill>
-                      <a:srgbClr val="F7F6F2"/>
-                    </a:solidFill>
-                  </a:tcPr>
-                </a:tc>
-              </a:tr>
-              <a:tr h="525780">
-                <a:tc>
-                  <a:txBody>
-                    <a:bodyPr/>
-                    <a:lstStyle/>
-                    <a:p>
-                      <a:r>
-                        <a:rPr sz="1300">
-                          <a:solidFill>
-                            <a:srgbClr val="3F4A4E"/>
-                          </a:solidFill>
-                          <a:latin typeface="Arial"/>
-                        </a:rPr>
-                        <a:t>Labor</a:t>
-                      </a:r>
-                    </a:p>
-                  </a:txBody>
-                  <a:tcPr>
-                    <a:solidFill>
-                      <a:srgbClr val="FFFFFF"/>
-                    </a:solidFill>
-                  </a:tcPr>
-                </a:tc>
-                <a:tc>
-                  <a:txBody>
-                    <a:bodyPr/>
-                    <a:lstStyle/>
-                    <a:p>
-                      <a:pPr algn="r"/>
-                      <a:r>
-                        <a:rPr sz="1300">
-                          <a:solidFill>
-                            <a:srgbClr val="3F4A4E"/>
-                          </a:solidFill>
-                          <a:latin typeface="Arial"/>
-                        </a:rPr>
-                        <a:t>19.0</a:t>
-                      </a:r>
-                    </a:p>
-                  </a:txBody>
-                  <a:tcPr>
-                    <a:solidFill>
-                      <a:srgbClr val="FFFFFF"/>
-                    </a:solidFill>
-                  </a:tcPr>
-                </a:tc>
-                <a:tc>
-                  <a:txBody>
-                    <a:bodyPr/>
-                    <a:lstStyle/>
-                    <a:p>
-                      <a:pPr algn="r"/>
-                      <a:r>
-                        <a:rPr sz="1300">
-                          <a:solidFill>
-                            <a:srgbClr val="3F4A4E"/>
-                          </a:solidFill>
-                          <a:latin typeface="Arial"/>
-                        </a:rPr>
-                        <a:t>14.7</a:t>
-                      </a:r>
-                    </a:p>
-                  </a:txBody>
-                  <a:tcPr>
-                    <a:solidFill>
-                      <a:srgbClr val="FFFFFF"/>
-                    </a:solidFill>
-                  </a:tcPr>
-                </a:tc>
-                <a:tc>
-                  <a:txBody>
-                    <a:bodyPr/>
-                    <a:lstStyle/>
-                    <a:p>
-                      <a:pPr algn="r"/>
-                      <a:r>
-                        <a:rPr sz="1300">
-                          <a:solidFill>
-                            <a:srgbClr val="3F4A4E"/>
-                          </a:solidFill>
-                          <a:latin typeface="Arial"/>
-                        </a:rPr>
-                        <a:t>19.0</a:t>
-                      </a:r>
-                    </a:p>
-                  </a:txBody>
-                  <a:tcPr>
-                    <a:solidFill>
-                      <a:srgbClr val="FFFFFF"/>
-                    </a:solidFill>
-                  </a:tcPr>
-                </a:tc>
-                <a:tc>
-                  <a:txBody>
-                    <a:bodyPr/>
-                    <a:lstStyle/>
-                    <a:p>
-                      <a:pPr algn="r"/>
-                      <a:r>
-                        <a:rPr sz="1300">
-                          <a:solidFill>
-                            <a:srgbClr val="3F4A4E"/>
-                          </a:solidFill>
-                          <a:latin typeface="Arial"/>
-                        </a:rPr>
-                        <a:t>14.7</a:t>
-                      </a:r>
-                    </a:p>
-                  </a:txBody>
-                  <a:tcPr>
-                    <a:solidFill>
-                      <a:srgbClr val="FFFFFF"/>
-                    </a:solidFill>
-                  </a:tcPr>
-                </a:tc>
-                <a:tc>
-                  <a:txBody>
-                    <a:bodyPr/>
-                    <a:lstStyle/>
-                    <a:p>
-                      <a:pPr algn="r"/>
-                      <a:r>
-                        <a:rPr sz="1300">
-                          <a:solidFill>
-                            <a:srgbClr val="3F4A4E"/>
-                          </a:solidFill>
-                          <a:latin typeface="Arial"/>
-                        </a:rPr>
-                        <a:t>17.8</a:t>
-                      </a:r>
-                    </a:p>
-                  </a:txBody>
-                  <a:tcPr>
-                    <a:solidFill>
-                      <a:srgbClr val="FFFFFF"/>
-                    </a:solidFill>
-                  </a:tcPr>
-                </a:tc>
-                <a:tc>
-                  <a:txBody>
-                    <a:bodyPr/>
-                    <a:lstStyle/>
-                    <a:p>
-                      <a:pPr algn="r"/>
-                      <a:r>
-                        <a:rPr sz="1300">
-                          <a:solidFill>
-                            <a:srgbClr val="3F4A4E"/>
-                          </a:solidFill>
-                          <a:latin typeface="Arial"/>
-                        </a:rPr>
-                        <a:t>17.2</a:t>
-                      </a:r>
-                    </a:p>
-                  </a:txBody>
-                  <a:tcPr>
-                    <a:solidFill>
-                      <a:srgbClr val="FFFFFF"/>
-                    </a:solidFill>
-                  </a:tcPr>
-                </a:tc>
-                <a:tc>
-                  <a:txBody>
-                    <a:bodyPr/>
-                    <a:lstStyle/>
-                    <a:p>
-                      <a:pPr algn="r"/>
-                      <a:r>
-                        <a:rPr sz="1300">
-                          <a:solidFill>
-                            <a:srgbClr val="3F4A4E"/>
-                          </a:solidFill>
-                          <a:latin typeface="Arial"/>
-                        </a:rPr>
-                        <a:t>17.2</a:t>
-                      </a:r>
-                    </a:p>
-                  </a:txBody>
-                  <a:tcPr>
-                    <a:solidFill>
-                      <a:srgbClr val="FFFFFF"/>
-                    </a:solidFill>
-                  </a:tcPr>
-                </a:tc>
-                <a:tc>
-                  <a:txBody>
-                    <a:bodyPr/>
-                    <a:lstStyle/>
-                    <a:p>
-                      <a:pPr algn="r"/>
-                      <a:r>
-                        <a:rPr sz="1300">
-                          <a:solidFill>
-                            <a:srgbClr val="3F4A4E"/>
-                          </a:solidFill>
-                          <a:latin typeface="Arial"/>
-                        </a:rPr>
-                        <a:t>17.2</a:t>
-                      </a:r>
-                    </a:p>
-                  </a:txBody>
-                  <a:tcPr>
-                    <a:solidFill>
-                      <a:srgbClr val="FFFFFF"/>
-                    </a:solidFill>
-                  </a:tcPr>
-                </a:tc>
-                <a:tc>
-                  <a:txBody>
-                    <a:bodyPr/>
-                    <a:lstStyle/>
-                    <a:p>
-                      <a:pPr algn="r"/>
-                      <a:r>
-                        <a:rPr sz="1300">
-                          <a:solidFill>
-                            <a:srgbClr val="3F4A4E"/>
-                          </a:solidFill>
-                          <a:latin typeface="Arial"/>
-                        </a:rPr>
-                        <a:t>17.2</a:t>
-                      </a:r>
-                    </a:p>
-                  </a:txBody>
-                  <a:tcPr>
-                    <a:solidFill>
-                      <a:srgbClr val="FFFFFF"/>
-                    </a:solidFill>
-                  </a:tcPr>
-                </a:tc>
-                <a:tc>
-                  <a:txBody>
-                    <a:bodyPr/>
-                    <a:lstStyle/>
-                    <a:p>
-                      <a:pPr algn="r"/>
-                      <a:r>
-                        <a:rPr sz="1300">
-                          <a:solidFill>
-                            <a:srgbClr val="3F4A4E"/>
-                          </a:solidFill>
-                          <a:latin typeface="Arial"/>
-                        </a:rPr>
-                        <a:t>17.2</a:t>
-                      </a:r>
-                    </a:p>
-                  </a:txBody>
-                  <a:tcPr>
-                    <a:solidFill>
-                      <a:srgbClr val="FFFFFF"/>
-                    </a:solidFill>
-                  </a:tcPr>
-                </a:tc>
-                <a:tc>
-                  <a:txBody>
-                    <a:bodyPr/>
-                    <a:lstStyle/>
-                    <a:p>
-                      <a:pPr algn="r"/>
-                      <a:r>
-                        <a:rPr sz="1300">
-                          <a:solidFill>
-                            <a:srgbClr val="3F4A4E"/>
-                          </a:solidFill>
-                          <a:latin typeface="Arial"/>
-                        </a:rPr>
-                        <a:t>17.2</a:t>
-                      </a:r>
-                    </a:p>
-                  </a:txBody>
-                  <a:tcPr>
-                    <a:solidFill>
-                      <a:srgbClr val="FFFFFF"/>
-                    </a:solidFill>
-                  </a:tcPr>
-                </a:tc>
-                <a:tc>
-                  <a:txBody>
-                    <a:bodyPr/>
-                    <a:lstStyle/>
-                    <a:p>
-                      <a:pPr algn="r"/>
-                      <a:r>
-                        <a:rPr sz="1300">
-                          <a:solidFill>
-                            <a:srgbClr val="3F4A4E"/>
-                          </a:solidFill>
-                          <a:latin typeface="Arial"/>
-                        </a:rPr>
-                        <a:t>13.4</a:t>
-                      </a:r>
-                    </a:p>
-                  </a:txBody>
-                  <a:tcPr>
-                    <a:solidFill>
-                      <a:srgbClr val="FFFFFF"/>
-                    </a:solidFill>
-                  </a:tcPr>
-                </a:tc>
-                <a:tc>
-                  <a:txBody>
-                    <a:bodyPr/>
-                    <a:lstStyle/>
-                    <a:p>
-                      <a:pPr algn="r"/>
-                      <a:r>
-                        <a:rPr sz="1300">
-                          <a:solidFill>
-                            <a:srgbClr val="3F4A4E"/>
-                          </a:solidFill>
-                          <a:latin typeface="Arial"/>
-                        </a:rPr>
-                        <a:t>201.8</a:t>
-                      </a:r>
-                    </a:p>
-                  </a:txBody>
-                  <a:tcPr>
-                    <a:solidFill>
-                      <a:srgbClr val="FFFFFF"/>
-                    </a:solidFill>
-                  </a:tcPr>
-                </a:tc>
-              </a:tr>
-              <a:tr h="525780">
-                <a:tc>
-                  <a:txBody>
-                    <a:bodyPr/>
-                    <a:lstStyle/>
-                    <a:p>
-                      <a:r>
-                        <a:rPr sz="1300">
-                          <a:solidFill>
-                            <a:srgbClr val="3F4A4E"/>
-                          </a:solidFill>
-                          <a:latin typeface="Arial"/>
-                        </a:rPr>
-                        <a:t>Controllable expenses</a:t>
-                      </a:r>
-                    </a:p>
-                  </a:txBody>
-                  <a:tcPr>
-                    <a:solidFill>
-                      <a:srgbClr val="F7F6F2"/>
-                    </a:solidFill>
-                  </a:tcPr>
-                </a:tc>
-                <a:tc>
-                  <a:txBody>
-                    <a:bodyPr/>
-                    <a:lstStyle/>
-                    <a:p>
-                      <a:pPr algn="r"/>
-                      <a:r>
-                        <a:rPr sz="1300">
-                          <a:solidFill>
-                            <a:srgbClr val="3F4A4E"/>
-                          </a:solidFill>
-                          <a:latin typeface="Arial"/>
-                        </a:rPr>
-                        <a:t>14.3</a:t>
-                      </a:r>
-                    </a:p>
-                  </a:txBody>
-                  <a:tcPr>
-                    <a:solidFill>
-                      <a:srgbClr val="F7F6F2"/>
-                    </a:solidFill>
-                  </a:tcPr>
-                </a:tc>
-                <a:tc>
-                  <a:txBody>
-                    <a:bodyPr/>
-                    <a:lstStyle/>
-                    <a:p>
-                      <a:pPr algn="r"/>
-                      <a:r>
-                        <a:rPr sz="1300">
-                          <a:solidFill>
-                            <a:srgbClr val="3F4A4E"/>
-                          </a:solidFill>
-                          <a:latin typeface="Arial"/>
-                        </a:rPr>
-                        <a:t>10.9</a:t>
-                      </a:r>
-                    </a:p>
-                  </a:txBody>
-                  <a:tcPr>
-                    <a:solidFill>
-                      <a:srgbClr val="F7F6F2"/>
-                    </a:solidFill>
-                  </a:tcPr>
-                </a:tc>
-                <a:tc>
-                  <a:txBody>
-                    <a:bodyPr/>
-                    <a:lstStyle/>
-                    <a:p>
-                      <a:pPr algn="r"/>
-                      <a:r>
-                        <a:rPr sz="1300">
-                          <a:solidFill>
-                            <a:srgbClr val="3F4A4E"/>
-                          </a:solidFill>
-                          <a:latin typeface="Arial"/>
-                        </a:rPr>
-                        <a:t>14.3</a:t>
-                      </a:r>
-                    </a:p>
-                  </a:txBody>
-                  <a:tcPr>
-                    <a:solidFill>
-                      <a:srgbClr val="F7F6F2"/>
-                    </a:solidFill>
-                  </a:tcPr>
-                </a:tc>
-                <a:tc>
-                  <a:txBody>
-                    <a:bodyPr/>
-                    <a:lstStyle/>
-                    <a:p>
-                      <a:pPr algn="r"/>
-                      <a:r>
-                        <a:rPr sz="1300">
-                          <a:solidFill>
-                            <a:srgbClr val="3F4A4E"/>
-                          </a:solidFill>
-                          <a:latin typeface="Arial"/>
-                        </a:rPr>
-                        <a:t>10.9</a:t>
-                      </a:r>
-                    </a:p>
-                  </a:txBody>
-                  <a:tcPr>
-                    <a:solidFill>
-                      <a:srgbClr val="F7F6F2"/>
-                    </a:solidFill>
-                  </a:tcPr>
-                </a:tc>
-                <a:tc>
-                  <a:txBody>
-                    <a:bodyPr/>
-                    <a:lstStyle/>
-                    <a:p>
-                      <a:pPr algn="r"/>
-                      <a:r>
-                        <a:rPr sz="1300">
-                          <a:solidFill>
-                            <a:srgbClr val="3F4A4E"/>
-                          </a:solidFill>
-                          <a:latin typeface="Arial"/>
-                        </a:rPr>
-                        <a:t>13.3</a:t>
-                      </a:r>
-                    </a:p>
-                  </a:txBody>
-                  <a:tcPr>
-                    <a:solidFill>
-                      <a:srgbClr val="F7F6F2"/>
-                    </a:solidFill>
-                  </a:tcPr>
-                </a:tc>
-                <a:tc>
-                  <a:txBody>
-                    <a:bodyPr/>
-                    <a:lstStyle/>
-                    <a:p>
-                      <a:pPr algn="r"/>
-                      <a:r>
-                        <a:rPr sz="1300">
-                          <a:solidFill>
-                            <a:srgbClr val="3F4A4E"/>
-                          </a:solidFill>
-                          <a:latin typeface="Arial"/>
-                        </a:rPr>
-                        <a:t>12.8</a:t>
-                      </a:r>
-                    </a:p>
-                  </a:txBody>
-                  <a:tcPr>
-                    <a:solidFill>
-                      <a:srgbClr val="F7F6F2"/>
-                    </a:solidFill>
-                  </a:tcPr>
-                </a:tc>
-                <a:tc>
-                  <a:txBody>
-                    <a:bodyPr/>
-                    <a:lstStyle/>
-                    <a:p>
-                      <a:pPr algn="r"/>
-                      <a:r>
-                        <a:rPr sz="1300">
-                          <a:solidFill>
-                            <a:srgbClr val="3F4A4E"/>
-                          </a:solidFill>
-                          <a:latin typeface="Arial"/>
-                        </a:rPr>
-                        <a:t>12.8</a:t>
-                      </a:r>
-                    </a:p>
-                  </a:txBody>
-                  <a:tcPr>
-                    <a:solidFill>
-                      <a:srgbClr val="F7F6F2"/>
-                    </a:solidFill>
-                  </a:tcPr>
-                </a:tc>
-                <a:tc>
-                  <a:txBody>
-                    <a:bodyPr/>
-                    <a:lstStyle/>
-                    <a:p>
-                      <a:pPr algn="r"/>
-                      <a:r>
-                        <a:rPr sz="1300">
-                          <a:solidFill>
-                            <a:srgbClr val="3F4A4E"/>
-                          </a:solidFill>
-                          <a:latin typeface="Arial"/>
-                        </a:rPr>
-                        <a:t>12.8</a:t>
-                      </a:r>
-                    </a:p>
-                  </a:txBody>
-                  <a:tcPr>
-                    <a:solidFill>
-                      <a:srgbClr val="F7F6F2"/>
-                    </a:solidFill>
-                  </a:tcPr>
-                </a:tc>
-                <a:tc>
-                  <a:txBody>
-                    <a:bodyPr/>
-                    <a:lstStyle/>
-                    <a:p>
-                      <a:pPr algn="r"/>
-                      <a:r>
-                        <a:rPr sz="1300">
-                          <a:solidFill>
-                            <a:srgbClr val="3F4A4E"/>
-                          </a:solidFill>
-                          <a:latin typeface="Arial"/>
-                        </a:rPr>
-                        <a:t>12.8</a:t>
-                      </a:r>
-                    </a:p>
-                  </a:txBody>
-                  <a:tcPr>
-                    <a:solidFill>
-                      <a:srgbClr val="F7F6F2"/>
-                    </a:solidFill>
-                  </a:tcPr>
-                </a:tc>
-                <a:tc>
-                  <a:txBody>
-                    <a:bodyPr/>
-                    <a:lstStyle/>
-                    <a:p>
-                      <a:pPr algn="r"/>
-                      <a:r>
-                        <a:rPr sz="1300">
-                          <a:solidFill>
-                            <a:srgbClr val="3F4A4E"/>
-                          </a:solidFill>
-                          <a:latin typeface="Arial"/>
-                        </a:rPr>
-                        <a:t>12.8</a:t>
-                      </a:r>
-                    </a:p>
-                  </a:txBody>
-                  <a:tcPr>
-                    <a:solidFill>
-                      <a:srgbClr val="F7F6F2"/>
-                    </a:solidFill>
-                  </a:tcPr>
-                </a:tc>
-                <a:tc>
-                  <a:txBody>
-                    <a:bodyPr/>
-                    <a:lstStyle/>
-                    <a:p>
-                      <a:pPr algn="r"/>
-                      <a:r>
-                        <a:rPr sz="1300">
-                          <a:solidFill>
-                            <a:srgbClr val="3F4A4E"/>
-                          </a:solidFill>
-                          <a:latin typeface="Arial"/>
-                        </a:rPr>
-                        <a:t>12.8</a:t>
-                      </a:r>
-                    </a:p>
-                  </a:txBody>
-                  <a:tcPr>
-                    <a:solidFill>
-                      <a:srgbClr val="F7F6F2"/>
-                    </a:solidFill>
-                  </a:tcPr>
-                </a:tc>
-                <a:tc>
-                  <a:txBody>
-                    <a:bodyPr/>
-                    <a:lstStyle/>
-                    <a:p>
-                      <a:pPr algn="r"/>
-                      <a:r>
-                        <a:rPr sz="1300">
-                          <a:solidFill>
-                            <a:srgbClr val="3F4A4E"/>
-                          </a:solidFill>
-                          <a:latin typeface="Arial"/>
-                        </a:rPr>
-                        <a:t>12.8</a:t>
-                      </a:r>
-                    </a:p>
-                  </a:txBody>
-                  <a:tcPr>
-                    <a:solidFill>
-                      <a:srgbClr val="F7F6F2"/>
-                    </a:solidFill>
-                  </a:tcPr>
-                </a:tc>
-                <a:tc>
-                  <a:txBody>
-                    <a:bodyPr/>
-                    <a:lstStyle/>
-                    <a:p>
-                      <a:pPr algn="r"/>
-                      <a:r>
-                        <a:rPr sz="1300">
-                          <a:solidFill>
-                            <a:srgbClr val="3F4A4E"/>
-                          </a:solidFill>
-                          <a:latin typeface="Arial"/>
-                        </a:rPr>
-                        <a:t>153.4</a:t>
-                      </a:r>
-                    </a:p>
-                  </a:txBody>
-                  <a:tcPr>
-                    <a:solidFill>
-                      <a:srgbClr val="F7F6F2"/>
-                    </a:solidFill>
-                  </a:tcPr>
-                </a:tc>
-              </a:tr>
-              <a:tr h="525780">
-                <a:tc>
-                  <a:txBody>
-                    <a:bodyPr/>
-                    <a:lstStyle/>
-                    <a:p>
-                      <a:r>
-                        <a:rPr sz="1300">
-                          <a:solidFill>
-                            <a:srgbClr val="3F4A4E"/>
-                          </a:solidFill>
-                          <a:latin typeface="Arial"/>
-                        </a:rPr>
-                        <a:t>Uncontrollable (incl 4% fee)</a:t>
-                      </a:r>
-                    </a:p>
-                  </a:txBody>
-                  <a:tcPr>
-                    <a:solidFill>
-                      <a:srgbClr val="FFFFFF"/>
-                    </a:solidFill>
-                  </a:tcPr>
-                </a:tc>
-                <a:tc>
-                  <a:txBody>
-                    <a:bodyPr/>
-                    <a:lstStyle/>
-                    <a:p>
-                      <a:pPr algn="r"/>
-                      <a:r>
-                        <a:rPr sz="1300">
-                          <a:solidFill>
-                            <a:srgbClr val="3F4A4E"/>
-                          </a:solidFill>
-                          <a:latin typeface="Arial"/>
-                        </a:rPr>
-                        <a:t>6.1</a:t>
-                      </a:r>
-                    </a:p>
-                  </a:txBody>
-                  <a:tcPr>
-                    <a:solidFill>
-                      <a:srgbClr val="FFFFFF"/>
-                    </a:solidFill>
-                  </a:tcPr>
-                </a:tc>
-                <a:tc>
-                  <a:txBody>
-                    <a:bodyPr/>
-                    <a:lstStyle/>
-                    <a:p>
-                      <a:pPr algn="r"/>
-                      <a:r>
-                        <a:rPr sz="1300">
-                          <a:solidFill>
-                            <a:srgbClr val="3F4A4E"/>
-                          </a:solidFill>
-                          <a:latin typeface="Arial"/>
-                        </a:rPr>
-                        <a:t>4.7</a:t>
-                      </a:r>
-                    </a:p>
-                  </a:txBody>
-                  <a:tcPr>
-                    <a:solidFill>
-                      <a:srgbClr val="FFFFFF"/>
-                    </a:solidFill>
-                  </a:tcPr>
-                </a:tc>
-                <a:tc>
-                  <a:txBody>
-                    <a:bodyPr/>
-                    <a:lstStyle/>
-                    <a:p>
-                      <a:pPr algn="r"/>
-                      <a:r>
-                        <a:rPr sz="1300">
-                          <a:solidFill>
-                            <a:srgbClr val="3F4A4E"/>
-                          </a:solidFill>
-                          <a:latin typeface="Arial"/>
-                        </a:rPr>
-                        <a:t>6.1</a:t>
-                      </a:r>
-                    </a:p>
-                  </a:txBody>
-                  <a:tcPr>
-                    <a:solidFill>
-                      <a:srgbClr val="FFFFFF"/>
-                    </a:solidFill>
-                  </a:tcPr>
-                </a:tc>
-                <a:tc>
-                  <a:txBody>
-                    <a:bodyPr/>
-                    <a:lstStyle/>
-                    <a:p>
-                      <a:pPr algn="r"/>
-                      <a:r>
-                        <a:rPr sz="1300">
-                          <a:solidFill>
-                            <a:srgbClr val="3F4A4E"/>
-                          </a:solidFill>
-                          <a:latin typeface="Arial"/>
-                        </a:rPr>
-                        <a:t>4.7</a:t>
-                      </a:r>
-                    </a:p>
-                  </a:txBody>
-                  <a:tcPr>
-                    <a:solidFill>
-                      <a:srgbClr val="FFFFFF"/>
-                    </a:solidFill>
-                  </a:tcPr>
-                </a:tc>
-                <a:tc>
-                  <a:txBody>
-                    <a:bodyPr/>
-                    <a:lstStyle/>
-                    <a:p>
-                      <a:pPr algn="r"/>
-                      <a:r>
-                        <a:rPr sz="1300">
-                          <a:solidFill>
-                            <a:srgbClr val="3F4A4E"/>
-                          </a:solidFill>
-                          <a:latin typeface="Arial"/>
-                        </a:rPr>
-                        <a:t>5.7</a:t>
-                      </a:r>
-                    </a:p>
-                  </a:txBody>
-                  <a:tcPr>
-                    <a:solidFill>
-                      <a:srgbClr val="FFFFFF"/>
-                    </a:solidFill>
-                  </a:tcPr>
-                </a:tc>
-                <a:tc>
-                  <a:txBody>
-                    <a:bodyPr/>
-                    <a:lstStyle/>
-                    <a:p>
-                      <a:pPr algn="r"/>
-                      <a:r>
-                        <a:rPr sz="1300">
-                          <a:solidFill>
-                            <a:srgbClr val="3F4A4E"/>
-                          </a:solidFill>
-                          <a:latin typeface="Arial"/>
-                        </a:rPr>
-                        <a:t>5.5</a:t>
-                      </a:r>
-                    </a:p>
-                  </a:txBody>
-                  <a:tcPr>
-                    <a:solidFill>
-                      <a:srgbClr val="FFFFFF"/>
-                    </a:solidFill>
-                  </a:tcPr>
-                </a:tc>
-                <a:tc>
-                  <a:txBody>
-                    <a:bodyPr/>
-                    <a:lstStyle/>
-                    <a:p>
-                      <a:pPr algn="r"/>
-                      <a:r>
-                        <a:rPr sz="1300">
-                          <a:solidFill>
-                            <a:srgbClr val="3F4A4E"/>
-                          </a:solidFill>
-                          <a:latin typeface="Arial"/>
-                        </a:rPr>
-                        <a:t>5.5</a:t>
-                      </a:r>
-                    </a:p>
-                  </a:txBody>
-                  <a:tcPr>
-                    <a:solidFill>
-                      <a:srgbClr val="FFFFFF"/>
-                    </a:solidFill>
-                  </a:tcPr>
-                </a:tc>
-                <a:tc>
-                  <a:txBody>
-                    <a:bodyPr/>
-                    <a:lstStyle/>
-                    <a:p>
-                      <a:pPr algn="r"/>
-                      <a:r>
-                        <a:rPr sz="1300">
-                          <a:solidFill>
-                            <a:srgbClr val="3F4A4E"/>
-                          </a:solidFill>
-                          <a:latin typeface="Arial"/>
-                        </a:rPr>
-                        <a:t>5.5</a:t>
-                      </a:r>
-                    </a:p>
-                  </a:txBody>
-                  <a:tcPr>
-                    <a:solidFill>
-                      <a:srgbClr val="FFFFFF"/>
-                    </a:solidFill>
-                  </a:tcPr>
-                </a:tc>
-                <a:tc>
-                  <a:txBody>
-                    <a:bodyPr/>
-                    <a:lstStyle/>
-                    <a:p>
-                      <a:pPr algn="r"/>
-                      <a:r>
-                        <a:rPr sz="1300">
-                          <a:solidFill>
-                            <a:srgbClr val="3F4A4E"/>
-                          </a:solidFill>
-                          <a:latin typeface="Arial"/>
-                        </a:rPr>
-                        <a:t>5.5</a:t>
-                      </a:r>
-                    </a:p>
-                  </a:txBody>
-                  <a:tcPr>
-                    <a:solidFill>
-                      <a:srgbClr val="FFFFFF"/>
-                    </a:solidFill>
-                  </a:tcPr>
-                </a:tc>
-                <a:tc>
-                  <a:txBody>
-                    <a:bodyPr/>
-                    <a:lstStyle/>
-                    <a:p>
-                      <a:pPr algn="r"/>
-                      <a:r>
-                        <a:rPr sz="1300">
-                          <a:solidFill>
-                            <a:srgbClr val="3F4A4E"/>
-                          </a:solidFill>
-                          <a:latin typeface="Arial"/>
-                        </a:rPr>
-                        <a:t>5.5</a:t>
-                      </a:r>
-                    </a:p>
-                  </a:txBody>
-                  <a:tcPr>
-                    <a:solidFill>
-                      <a:srgbClr val="FFFFFF"/>
-                    </a:solidFill>
-                  </a:tcPr>
-                </a:tc>
-                <a:tc>
-                  <a:txBody>
-                    <a:bodyPr/>
-                    <a:lstStyle/>
-                    <a:p>
-                      <a:pPr algn="r"/>
-                      <a:r>
-                        <a:rPr sz="1300">
-                          <a:solidFill>
-                            <a:srgbClr val="3F4A4E"/>
-                          </a:solidFill>
-                          <a:latin typeface="Arial"/>
-                        </a:rPr>
-                        <a:t>5.5</a:t>
-                      </a:r>
-                    </a:p>
-                  </a:txBody>
-                  <a:tcPr>
-                    <a:solidFill>
-                      <a:srgbClr val="FFFFFF"/>
-                    </a:solidFill>
-                  </a:tcPr>
-                </a:tc>
-                <a:tc>
-                  <a:txBody>
-                    <a:bodyPr/>
-                    <a:lstStyle/>
-                    <a:p>
-                      <a:pPr algn="r"/>
-                      <a:r>
-                        <a:rPr sz="1300">
-                          <a:solidFill>
-                            <a:srgbClr val="3F4A4E"/>
-                          </a:solidFill>
-                          <a:latin typeface="Arial"/>
-                        </a:rPr>
-                        <a:t>5.5</a:t>
-                      </a:r>
-                    </a:p>
-                  </a:txBody>
-                  <a:tcPr>
-                    <a:solidFill>
-                      <a:srgbClr val="FFFFFF"/>
-                    </a:solidFill>
-                  </a:tcPr>
-                </a:tc>
-                <a:tc>
-                  <a:txBody>
-                    <a:bodyPr/>
-                    <a:lstStyle/>
-                    <a:p>
-                      <a:pPr algn="r"/>
-                      <a:r>
-                        <a:rPr sz="1300">
-                          <a:solidFill>
-                            <a:srgbClr val="3F4A4E"/>
-                          </a:solidFill>
-                          <a:latin typeface="Arial"/>
-                        </a:rPr>
-                        <a:t>66.0</a:t>
-                      </a:r>
-                    </a:p>
-                  </a:txBody>
-                  <a:tcPr>
-                    <a:solidFill>
-                      <a:srgbClr val="FFFFFF"/>
-                    </a:solidFill>
-                  </a:tcPr>
-                </a:tc>
-              </a:tr>
-              <a:tr h="525780">
-                <a:tc>
-                  <a:txBody>
-                    <a:bodyPr/>
-                    <a:lstStyle/>
-                    <a:p>
-                      <a:r>
-                        <a:rPr sz="1300" b="1">
-                          <a:solidFill>
-                            <a:srgbClr val="22424B"/>
-                          </a:solidFill>
-                          <a:latin typeface="Arial"/>
-                        </a:rPr>
-                        <a:t>NET OPERATING PROFIT</a:t>
-                      </a:r>
-                    </a:p>
-                  </a:txBody>
-                  <a:tcPr>
-                    <a:solidFill>
-                      <a:srgbClr val="F7F6F2"/>
-                    </a:solidFill>
-                  </a:tcPr>
-                </a:tc>
-                <a:tc>
-                  <a:txBody>
-                    <a:bodyPr/>
-                    <a:lstStyle/>
-                    <a:p>
-                      <a:pPr algn="r"/>
-                      <a:r>
-                        <a:rPr sz="1300" b="1">
-                          <a:solidFill>
-                            <a:srgbClr val="22424B"/>
-                          </a:solidFill>
-                          <a:latin typeface="Arial"/>
-                        </a:rPr>
-                        <a:t>9.1</a:t>
-                      </a:r>
-                    </a:p>
-                  </a:txBody>
-                  <a:tcPr>
-                    <a:solidFill>
-                      <a:srgbClr val="F7F6F2"/>
-                    </a:solidFill>
-                  </a:tcPr>
-                </a:tc>
-                <a:tc>
-                  <a:txBody>
-                    <a:bodyPr/>
-                    <a:lstStyle/>
-                    <a:p>
-                      <a:pPr algn="r"/>
-                      <a:r>
-                        <a:rPr sz="1300" b="1">
-                          <a:solidFill>
-                            <a:srgbClr val="22424B"/>
-                          </a:solidFill>
-                          <a:latin typeface="Arial"/>
-                        </a:rPr>
-                        <a:t>(2.6)</a:t>
-                      </a:r>
-                    </a:p>
-                  </a:txBody>
-                  <a:tcPr>
-                    <a:solidFill>
-                      <a:srgbClr val="F7F6F2"/>
-                    </a:solidFill>
-                  </a:tcPr>
-                </a:tc>
-                <a:tc>
-                  <a:txBody>
-                    <a:bodyPr/>
-                    <a:lstStyle/>
-                    <a:p>
-                      <a:pPr algn="r"/>
-                      <a:r>
-                        <a:rPr sz="1300" b="1">
-                          <a:solidFill>
-                            <a:srgbClr val="22424B"/>
-                          </a:solidFill>
-                          <a:latin typeface="Arial"/>
-                        </a:rPr>
-                        <a:t>9.1</a:t>
-                      </a:r>
-                    </a:p>
-                  </a:txBody>
-                  <a:tcPr>
-                    <a:solidFill>
-                      <a:srgbClr val="F7F6F2"/>
-                    </a:solidFill>
-                  </a:tcPr>
-                </a:tc>
-                <a:tc>
-                  <a:txBody>
-                    <a:bodyPr/>
-                    <a:lstStyle/>
-                    <a:p>
-                      <a:pPr algn="r"/>
-                      <a:r>
-                        <a:rPr sz="1300" b="1">
-                          <a:solidFill>
-                            <a:srgbClr val="22424B"/>
-                          </a:solidFill>
-                          <a:latin typeface="Arial"/>
-                        </a:rPr>
-                        <a:t>(2.6)</a:t>
-                      </a:r>
-                    </a:p>
-                  </a:txBody>
-                  <a:tcPr>
-                    <a:solidFill>
-                      <a:srgbClr val="F7F6F2"/>
-                    </a:solidFill>
-                  </a:tcPr>
-                </a:tc>
-                <a:tc>
-                  <a:txBody>
-                    <a:bodyPr/>
-                    <a:lstStyle/>
-                    <a:p>
-                      <a:pPr algn="r"/>
-                      <a:r>
-                        <a:rPr sz="1300" b="1">
-                          <a:solidFill>
-                            <a:srgbClr val="22424B"/>
-                          </a:solidFill>
-                          <a:latin typeface="Arial"/>
-                        </a:rPr>
-                        <a:t>5.8</a:t>
-                      </a:r>
-                    </a:p>
-                  </a:txBody>
-                  <a:tcPr>
-                    <a:solidFill>
-                      <a:srgbClr val="F7F6F2"/>
-                    </a:solidFill>
-                  </a:tcPr>
-                </a:tc>
-                <a:tc>
-                  <a:txBody>
-                    <a:bodyPr/>
-                    <a:lstStyle/>
-                    <a:p>
-                      <a:pPr algn="r"/>
-                      <a:r>
-                        <a:rPr sz="1300" b="1">
-                          <a:solidFill>
-                            <a:srgbClr val="22424B"/>
-                          </a:solidFill>
-                          <a:latin typeface="Arial"/>
-                        </a:rPr>
-                        <a:t>4.1</a:t>
-                      </a:r>
-                    </a:p>
-                  </a:txBody>
-                  <a:tcPr>
-                    <a:solidFill>
-                      <a:srgbClr val="F7F6F2"/>
-                    </a:solidFill>
-                  </a:tcPr>
-                </a:tc>
-                <a:tc>
-                  <a:txBody>
-                    <a:bodyPr/>
-                    <a:lstStyle/>
-                    <a:p>
-                      <a:pPr algn="r"/>
-                      <a:r>
-                        <a:rPr sz="1300" b="1">
-                          <a:solidFill>
-                            <a:srgbClr val="22424B"/>
-                          </a:solidFill>
-                          <a:latin typeface="Arial"/>
-                        </a:rPr>
-                        <a:t>4.1</a:t>
-                      </a:r>
-                    </a:p>
-                  </a:txBody>
-                  <a:tcPr>
-                    <a:solidFill>
-                      <a:srgbClr val="F7F6F2"/>
-                    </a:solidFill>
-                  </a:tcPr>
-                </a:tc>
-                <a:tc>
-                  <a:txBody>
-                    <a:bodyPr/>
-                    <a:lstStyle/>
-                    <a:p>
-                      <a:pPr algn="r"/>
-                      <a:r>
-                        <a:rPr sz="1300" b="1">
-                          <a:solidFill>
-                            <a:srgbClr val="22424B"/>
-                          </a:solidFill>
-                          <a:latin typeface="Arial"/>
-                        </a:rPr>
-                        <a:t>4.1</a:t>
-                      </a:r>
-                    </a:p>
-                  </a:txBody>
-                  <a:tcPr>
-                    <a:solidFill>
-                      <a:srgbClr val="F7F6F2"/>
-                    </a:solidFill>
-                  </a:tcPr>
-                </a:tc>
-                <a:tc>
-                  <a:txBody>
-                    <a:bodyPr/>
-                    <a:lstStyle/>
-                    <a:p>
-                      <a:pPr algn="r"/>
-                      <a:r>
-                        <a:rPr sz="1300" b="1">
-                          <a:solidFill>
-                            <a:srgbClr val="22424B"/>
-                          </a:solidFill>
-                          <a:latin typeface="Arial"/>
-                        </a:rPr>
-                        <a:t>4.1</a:t>
-                      </a:r>
-                    </a:p>
-                  </a:txBody>
-                  <a:tcPr>
-                    <a:solidFill>
-                      <a:srgbClr val="F7F6F2"/>
-                    </a:solidFill>
-                  </a:tcPr>
-                </a:tc>
-                <a:tc>
-                  <a:txBody>
-                    <a:bodyPr/>
-                    <a:lstStyle/>
-                    <a:p>
-                      <a:pPr algn="r"/>
-                      <a:r>
-                        <a:rPr sz="1300" b="1">
-                          <a:solidFill>
-                            <a:srgbClr val="22424B"/>
-                          </a:solidFill>
-                          <a:latin typeface="Arial"/>
-                        </a:rPr>
-                        <a:t>4.1</a:t>
-                      </a:r>
-                    </a:p>
-                  </a:txBody>
-                  <a:tcPr>
-                    <a:solidFill>
-                      <a:srgbClr val="F7F6F2"/>
-                    </a:solidFill>
-                  </a:tcPr>
-                </a:tc>
-                <a:tc>
-                  <a:txBody>
-                    <a:bodyPr/>
-                    <a:lstStyle/>
-                    <a:p>
-                      <a:pPr algn="r"/>
-                      <a:r>
-                        <a:rPr sz="1300" b="1">
-                          <a:solidFill>
-                            <a:srgbClr val="22424B"/>
-                          </a:solidFill>
-                          <a:latin typeface="Arial"/>
-                        </a:rPr>
-                        <a:t>4.1</a:t>
-                      </a:r>
-                    </a:p>
-                  </a:txBody>
-                  <a:tcPr>
-                    <a:solidFill>
-                      <a:srgbClr val="F7F6F2"/>
-                    </a:solidFill>
-                  </a:tcPr>
-                </a:tc>
-                <a:tc>
-                  <a:txBody>
-                    <a:bodyPr/>
-                    <a:lstStyle/>
-                    <a:p>
-                      <a:pPr algn="r"/>
-                      <a:r>
-                        <a:rPr sz="1300" b="1">
-                          <a:solidFill>
-                            <a:srgbClr val="22424B"/>
-                          </a:solidFill>
-                          <a:latin typeface="Arial"/>
-                        </a:rPr>
-                        <a:t>7.9</a:t>
-                      </a:r>
-                    </a:p>
-                  </a:txBody>
-                  <a:tcPr>
-                    <a:solidFill>
-                      <a:srgbClr val="F7F6F2"/>
-                    </a:solidFill>
-                  </a:tcPr>
-                </a:tc>
-                <a:tc>
-                  <a:txBody>
-                    <a:bodyPr/>
-                    <a:lstStyle/>
-                    <a:p>
-                      <a:pPr algn="r"/>
-                      <a:r>
-                        <a:rPr sz="1300" b="1">
-                          <a:solidFill>
-                            <a:srgbClr val="22424B"/>
-                          </a:solidFill>
-                          <a:latin typeface="Arial"/>
-                        </a:rPr>
-                        <a:t>51.4</a:t>
-                      </a:r>
-                    </a:p>
-                  </a:txBody>
-                  <a:tcPr>
-                    <a:solidFill>
-                      <a:srgbClr val="F7F6F2"/>
-                    </a:solidFill>
-                  </a:tcPr>
-                </a:tc>
-              </a:tr>
-            </a:tbl>
-          </a:graphicData>
-        </a:graphic>
-      </p:graphicFrame>
-      <p:sp>
-        <p:nvSpPr>
-          <p:cNvPr id="5" name="TextBox 4"/>
-          <p:cNvSpPr txBox="1"/>
-          <p:nvPr/>
-        </p:nvSpPr>
-        <p:spPr>
-          <a:xfrm>
-            <a:off x="950976" y="6949440"/>
-            <a:ext cx="16367759" cy="1097280"/>
-          </a:xfrm>
-          <a:prstGeom prst="rect">
-            <a:avLst/>
-          </a:prstGeom>
-          <a:noFill/>
-        </p:spPr>
-        <p:txBody>
-          <a:bodyPr wrap="square">
-            <a:spAutoFit/>
-          </a:bodyPr>
-          <a:lstStyle/>
-          <a:p>
-            <a:r>
-              <a:rPr sz="1200">
+              <a:rPr sz="1100">
                 <a:solidFill>
                   <a:srgbClr val="3F4A4E"/>
                 </a:solidFill>
                 <a:latin typeface="Arial"/>
               </a:rPr>
-              <a:t>Vessel + Little Wing. Monthly shape follows Vessel’s event calendar (Jan/Mar run 13 events, Feb/Apr 4) over Little Wing’s flat forecast run-rate; ten of twelve months are profitable, with Feb/Apr dips from light event months. December includes the labor true-up. Source: Combined 12-Mo P&amp;L tab, Method_Operating_Model_2027_22.xlsx — every line recalculates from the assumption inputs.</a:t>
+              <a:t>Rendered directly from the Combined 12-Mo P&amp;L tab, Method_Operating_Model_2027_22.xlsx — Vessel + Little Wing, all levers in effect. FY NOP $51,360; ten of twelve months profitable (Feb/Apr dips = 3-event months at Vessel).</a:t>
             </a:r>
           </a:p>
         </p:txBody>

</xml_diff>

<commit_message>
Fit monthly P&L exhibit within slide bounds
Co-Authored-By: Claude Fable 5 <noreply@anthropic.com>
Claude-Session: https://claude.ai/code/session_01VCQW3YoSqaJfwSKLPDyQy8
</commit_message>
<xml_diff>
--- a/Consolidated_Slides_Insert.pptx
+++ b/Consolidated_Slides_Insert.pptx
@@ -4214,8 +4214,8 @@
         </p:nvSpPr>
         <p:spPr>
           <a:xfrm>
-            <a:off x="950976" y="457200"/>
-            <a:ext cx="16459200" cy="320040"/>
+            <a:off x="950976" y="292608"/>
+            <a:ext cx="16459200" cy="292608"/>
           </a:xfrm>
           <a:prstGeom prst="rect">
             <a:avLst/>
@@ -4229,7 +4229,7 @@
           <a:lstStyle/>
           <a:p>
             <a:r>
-              <a:rPr sz="1650" b="1">
+              <a:rPr sz="1500" b="1">
                 <a:solidFill>
                   <a:srgbClr val="1E7E8C"/>
                 </a:solidFill>
@@ -4242,7 +4242,7 @@
       </p:sp>
       <p:pic>
         <p:nvPicPr>
-          <p:cNvPr id="3" name="Picture 2" descr="combined_pnl_exhibit.png"/>
+          <p:cNvPr id="3" name="Picture 2" descr="image.png"/>
           <p:cNvPicPr>
             <a:picLocks noChangeAspect="1"/>
           </p:cNvPicPr>
@@ -4256,8 +4256,8 @@
         </p:blipFill>
         <p:spPr>
           <a:xfrm>
-            <a:off x="640079" y="960120"/>
-            <a:ext cx="17007840" cy="10117855"/>
+            <a:off x="1650727" y="713232"/>
+            <a:ext cx="14986545" cy="8915400"/>
           </a:xfrm>
           <a:prstGeom prst="rect">
             <a:avLst/>
@@ -4272,8 +4272,8 @@
         </p:nvSpPr>
         <p:spPr>
           <a:xfrm>
-            <a:off x="950976" y="11215135"/>
-            <a:ext cx="16367759" cy="365760"/>
+            <a:off x="950976" y="9710928"/>
+            <a:ext cx="16367759" cy="411480"/>
           </a:xfrm>
           <a:prstGeom prst="rect">
             <a:avLst/>
@@ -4287,13 +4287,13 @@
           <a:lstStyle/>
           <a:p>
             <a:r>
-              <a:rPr sz="1100">
+              <a:rPr sz="1050">
                 <a:solidFill>
                   <a:srgbClr val="3F4A4E"/>
                 </a:solidFill>
                 <a:latin typeface="Arial"/>
               </a:rPr>
-              <a:t>Rendered directly from the Combined 12-Mo P&amp;L tab, Method_Operating_Model_2027_22.xlsx — Vessel + Little Wing, all levers in effect. FY NOP $51,360; ten of twelve months profitable (Feb/Apr dips = 3-event months at Vessel).</a:t>
+              <a:t>Rendered from the Combined 12-Mo P&amp;L tab, Method_Operating_Model_2027_22.xlsx — Vessel + Little Wing, all levers in effect. FY NOP $51,360; ten of twelve months profitable (Feb/Apr dips = 3-event months at Vessel).</a:t>
             </a:r>
           </a:p>
         </p:txBody>

</xml_diff>

<commit_message>
Monthly P&L slide: native deck-style table, 8 summary lines by month
Replaces the rendered-exhibit approach per direction: revenue, COGS,
labor, prime cost, operating profit, controllable, uncontrollable,
NOP x 12 months + FY, in the deck aesthetic.

Co-Authored-By: Claude Fable 5 <noreply@anthropic.com>
Claude-Session: https://claude.ai/code/session_01VCQW3YoSqaJfwSKLPDyQy8
</commit_message>
<xml_diff>
--- a/Consolidated_Slides_Insert.pptx
+++ b/Consolidated_Slides_Insert.pptx
@@ -4214,8 +4214,8 @@
         </p:nvSpPr>
         <p:spPr>
           <a:xfrm>
-            <a:off x="950976" y="292608"/>
-            <a:ext cx="16459200" cy="292608"/>
+            <a:off x="950976" y="740664"/>
+            <a:ext cx="16459200" cy="320040"/>
           </a:xfrm>
           <a:prstGeom prst="rect">
             <a:avLst/>
@@ -4229,51 +4229,27 @@
           <a:lstStyle/>
           <a:p>
             <a:r>
-              <a:rPr sz="1500" b="1">
+              <a:rPr sz="1650" b="1">
                 <a:solidFill>
                   <a:srgbClr val="1E7E8C"/>
                 </a:solidFill>
                 <a:latin typeface="Arial"/>
               </a:rPr>
-              <a:t>CONSOLIDATED | 2027 MONTHLY P&amp;L</a:t>
+              <a:t>CONSOLIDATED | P&amp;L</a:t>
             </a:r>
           </a:p>
         </p:txBody>
       </p:sp>
-      <p:pic>
-        <p:nvPicPr>
-          <p:cNvPr id="3" name="Picture 2" descr="image.png"/>
-          <p:cNvPicPr>
-            <a:picLocks noChangeAspect="1"/>
-          </p:cNvPicPr>
-          <p:nvPr/>
-        </p:nvPicPr>
-        <p:blipFill>
-          <a:blip r:embed="rId2"/>
-          <a:stretch>
-            <a:fillRect/>
-          </a:stretch>
-        </p:blipFill>
-        <p:spPr>
-          <a:xfrm>
-            <a:off x="1650727" y="713232"/>
-            <a:ext cx="14986545" cy="8915400"/>
-          </a:xfrm>
-          <a:prstGeom prst="rect">
-            <a:avLst/>
-          </a:prstGeom>
-        </p:spPr>
-      </p:pic>
       <p:sp>
         <p:nvSpPr>
-          <p:cNvPr id="4" name="TextBox 3"/>
+          <p:cNvPr id="3" name="TextBox 2"/>
           <p:cNvSpPr txBox="1"/>
           <p:nvPr/>
         </p:nvSpPr>
         <p:spPr>
           <a:xfrm>
-            <a:off x="950976" y="9710928"/>
-            <a:ext cx="16367759" cy="411480"/>
+            <a:off x="950976" y="1106424"/>
+            <a:ext cx="16459200" cy="640080"/>
           </a:xfrm>
           <a:prstGeom prst="rect">
             <a:avLst/>
@@ -4287,13 +4263,2992 @@
           <a:lstStyle/>
           <a:p>
             <a:r>
-              <a:rPr sz="1050">
+              <a:rPr sz="4000">
+                <a:solidFill>
+                  <a:srgbClr val="22424B"/>
+                </a:solidFill>
+                <a:latin typeface="Georgia"/>
+              </a:rPr>
+              <a:t>2027 by month</a:t>
+            </a:r>
+          </a:p>
+        </p:txBody>
+      </p:sp>
+      <p:graphicFrame>
+        <p:nvGraphicFramePr>
+          <p:cNvPr id="4" name="Table 3"/>
+          <p:cNvGraphicFramePr>
+            <a:graphicFrameLocks noGrp="1"/>
+          </p:cNvGraphicFramePr>
+          <p:nvPr/>
+        </p:nvGraphicFramePr>
+        <p:xfrm>
+          <a:off x="640080" y="2468880"/>
+          <a:ext cx="17007832" cy="4937760"/>
+        </p:xfrm>
+        <a:graphic>
+          <a:graphicData uri="http://schemas.openxmlformats.org/drawingml/2006/table">
+            <a:tbl>
+              <a:tblPr firstRow="1" bandRow="1">
+                <a:tableStyleId>{5C22544A-7EE6-4342-B048-85BDC9FD1C3A}</a:tableStyleId>
+              </a:tblPr>
+              <a:tblGrid>
+                <a:gridCol w="3108960"/>
+                <a:gridCol w="1069144"/>
+                <a:gridCol w="1069144"/>
+                <a:gridCol w="1069144"/>
+                <a:gridCol w="1069144"/>
+                <a:gridCol w="1069144"/>
+                <a:gridCol w="1069144"/>
+                <a:gridCol w="1069144"/>
+                <a:gridCol w="1069144"/>
+                <a:gridCol w="1069144"/>
+                <a:gridCol w="1069144"/>
+                <a:gridCol w="1069144"/>
+                <a:gridCol w="1069144"/>
+                <a:gridCol w="1069144"/>
+              </a:tblGrid>
+              <a:tr h="548640">
+                <a:tc>
+                  <a:txBody>
+                    <a:bodyPr/>
+                    <a:lstStyle/>
+                    <a:p>
+                      <a:r>
+                        <a:rPr sz="1100" b="1">
+                          <a:solidFill>
+                            <a:srgbClr val="FFFFFF"/>
+                          </a:solidFill>
+                          <a:latin typeface="Arial"/>
+                        </a:rPr>
+                        <a:t>$ thousands</a:t>
+                      </a:r>
+                    </a:p>
+                  </a:txBody>
+                  <a:tcPr>
+                    <a:solidFill>
+                      <a:srgbClr val="22424B"/>
+                    </a:solidFill>
+                  </a:tcPr>
+                </a:tc>
+                <a:tc>
+                  <a:txBody>
+                    <a:bodyPr/>
+                    <a:lstStyle/>
+                    <a:p>
+                      <a:pPr algn="r"/>
+                      <a:r>
+                        <a:rPr sz="1100" b="1">
+                          <a:solidFill>
+                            <a:srgbClr val="FFFFFF"/>
+                          </a:solidFill>
+                          <a:latin typeface="Arial"/>
+                        </a:rPr>
+                        <a:t>JAN</a:t>
+                      </a:r>
+                    </a:p>
+                  </a:txBody>
+                  <a:tcPr>
+                    <a:solidFill>
+                      <a:srgbClr val="22424B"/>
+                    </a:solidFill>
+                  </a:tcPr>
+                </a:tc>
+                <a:tc>
+                  <a:txBody>
+                    <a:bodyPr/>
+                    <a:lstStyle/>
+                    <a:p>
+                      <a:pPr algn="r"/>
+                      <a:r>
+                        <a:rPr sz="1100" b="1">
+                          <a:solidFill>
+                            <a:srgbClr val="FFFFFF"/>
+                          </a:solidFill>
+                          <a:latin typeface="Arial"/>
+                        </a:rPr>
+                        <a:t>FEB</a:t>
+                      </a:r>
+                    </a:p>
+                  </a:txBody>
+                  <a:tcPr>
+                    <a:solidFill>
+                      <a:srgbClr val="22424B"/>
+                    </a:solidFill>
+                  </a:tcPr>
+                </a:tc>
+                <a:tc>
+                  <a:txBody>
+                    <a:bodyPr/>
+                    <a:lstStyle/>
+                    <a:p>
+                      <a:pPr algn="r"/>
+                      <a:r>
+                        <a:rPr sz="1100" b="1">
+                          <a:solidFill>
+                            <a:srgbClr val="FFFFFF"/>
+                          </a:solidFill>
+                          <a:latin typeface="Arial"/>
+                        </a:rPr>
+                        <a:t>MAR</a:t>
+                      </a:r>
+                    </a:p>
+                  </a:txBody>
+                  <a:tcPr>
+                    <a:solidFill>
+                      <a:srgbClr val="22424B"/>
+                    </a:solidFill>
+                  </a:tcPr>
+                </a:tc>
+                <a:tc>
+                  <a:txBody>
+                    <a:bodyPr/>
+                    <a:lstStyle/>
+                    <a:p>
+                      <a:pPr algn="r"/>
+                      <a:r>
+                        <a:rPr sz="1100" b="1">
+                          <a:solidFill>
+                            <a:srgbClr val="FFFFFF"/>
+                          </a:solidFill>
+                          <a:latin typeface="Arial"/>
+                        </a:rPr>
+                        <a:t>APR</a:t>
+                      </a:r>
+                    </a:p>
+                  </a:txBody>
+                  <a:tcPr>
+                    <a:solidFill>
+                      <a:srgbClr val="22424B"/>
+                    </a:solidFill>
+                  </a:tcPr>
+                </a:tc>
+                <a:tc>
+                  <a:txBody>
+                    <a:bodyPr/>
+                    <a:lstStyle/>
+                    <a:p>
+                      <a:pPr algn="r"/>
+                      <a:r>
+                        <a:rPr sz="1100" b="1">
+                          <a:solidFill>
+                            <a:srgbClr val="FFFFFF"/>
+                          </a:solidFill>
+                          <a:latin typeface="Arial"/>
+                        </a:rPr>
+                        <a:t>MAY</a:t>
+                      </a:r>
+                    </a:p>
+                  </a:txBody>
+                  <a:tcPr>
+                    <a:solidFill>
+                      <a:srgbClr val="22424B"/>
+                    </a:solidFill>
+                  </a:tcPr>
+                </a:tc>
+                <a:tc>
+                  <a:txBody>
+                    <a:bodyPr/>
+                    <a:lstStyle/>
+                    <a:p>
+                      <a:pPr algn="r"/>
+                      <a:r>
+                        <a:rPr sz="1100" b="1">
+                          <a:solidFill>
+                            <a:srgbClr val="FFFFFF"/>
+                          </a:solidFill>
+                          <a:latin typeface="Arial"/>
+                        </a:rPr>
+                        <a:t>JUN</a:t>
+                      </a:r>
+                    </a:p>
+                  </a:txBody>
+                  <a:tcPr>
+                    <a:solidFill>
+                      <a:srgbClr val="22424B"/>
+                    </a:solidFill>
+                  </a:tcPr>
+                </a:tc>
+                <a:tc>
+                  <a:txBody>
+                    <a:bodyPr/>
+                    <a:lstStyle/>
+                    <a:p>
+                      <a:pPr algn="r"/>
+                      <a:r>
+                        <a:rPr sz="1100" b="1">
+                          <a:solidFill>
+                            <a:srgbClr val="FFFFFF"/>
+                          </a:solidFill>
+                          <a:latin typeface="Arial"/>
+                        </a:rPr>
+                        <a:t>JUL</a:t>
+                      </a:r>
+                    </a:p>
+                  </a:txBody>
+                  <a:tcPr>
+                    <a:solidFill>
+                      <a:srgbClr val="22424B"/>
+                    </a:solidFill>
+                  </a:tcPr>
+                </a:tc>
+                <a:tc>
+                  <a:txBody>
+                    <a:bodyPr/>
+                    <a:lstStyle/>
+                    <a:p>
+                      <a:pPr algn="r"/>
+                      <a:r>
+                        <a:rPr sz="1100" b="1">
+                          <a:solidFill>
+                            <a:srgbClr val="FFFFFF"/>
+                          </a:solidFill>
+                          <a:latin typeface="Arial"/>
+                        </a:rPr>
+                        <a:t>AUG</a:t>
+                      </a:r>
+                    </a:p>
+                  </a:txBody>
+                  <a:tcPr>
+                    <a:solidFill>
+                      <a:srgbClr val="22424B"/>
+                    </a:solidFill>
+                  </a:tcPr>
+                </a:tc>
+                <a:tc>
+                  <a:txBody>
+                    <a:bodyPr/>
+                    <a:lstStyle/>
+                    <a:p>
+                      <a:pPr algn="r"/>
+                      <a:r>
+                        <a:rPr sz="1100" b="1">
+                          <a:solidFill>
+                            <a:srgbClr val="FFFFFF"/>
+                          </a:solidFill>
+                          <a:latin typeface="Arial"/>
+                        </a:rPr>
+                        <a:t>SEP</a:t>
+                      </a:r>
+                    </a:p>
+                  </a:txBody>
+                  <a:tcPr>
+                    <a:solidFill>
+                      <a:srgbClr val="22424B"/>
+                    </a:solidFill>
+                  </a:tcPr>
+                </a:tc>
+                <a:tc>
+                  <a:txBody>
+                    <a:bodyPr/>
+                    <a:lstStyle/>
+                    <a:p>
+                      <a:pPr algn="r"/>
+                      <a:r>
+                        <a:rPr sz="1100" b="1">
+                          <a:solidFill>
+                            <a:srgbClr val="FFFFFF"/>
+                          </a:solidFill>
+                          <a:latin typeface="Arial"/>
+                        </a:rPr>
+                        <a:t>OCT</a:t>
+                      </a:r>
+                    </a:p>
+                  </a:txBody>
+                  <a:tcPr>
+                    <a:solidFill>
+                      <a:srgbClr val="22424B"/>
+                    </a:solidFill>
+                  </a:tcPr>
+                </a:tc>
+                <a:tc>
+                  <a:txBody>
+                    <a:bodyPr/>
+                    <a:lstStyle/>
+                    <a:p>
+                      <a:pPr algn="r"/>
+                      <a:r>
+                        <a:rPr sz="1100" b="1">
+                          <a:solidFill>
+                            <a:srgbClr val="FFFFFF"/>
+                          </a:solidFill>
+                          <a:latin typeface="Arial"/>
+                        </a:rPr>
+                        <a:t>NOV</a:t>
+                      </a:r>
+                    </a:p>
+                  </a:txBody>
+                  <a:tcPr>
+                    <a:solidFill>
+                      <a:srgbClr val="22424B"/>
+                    </a:solidFill>
+                  </a:tcPr>
+                </a:tc>
+                <a:tc>
+                  <a:txBody>
+                    <a:bodyPr/>
+                    <a:lstStyle/>
+                    <a:p>
+                      <a:pPr algn="r"/>
+                      <a:r>
+                        <a:rPr sz="1100" b="1">
+                          <a:solidFill>
+                            <a:srgbClr val="FFFFFF"/>
+                          </a:solidFill>
+                          <a:latin typeface="Arial"/>
+                        </a:rPr>
+                        <a:t>DEC</a:t>
+                      </a:r>
+                    </a:p>
+                  </a:txBody>
+                  <a:tcPr>
+                    <a:solidFill>
+                      <a:srgbClr val="22424B"/>
+                    </a:solidFill>
+                  </a:tcPr>
+                </a:tc>
+                <a:tc>
+                  <a:txBody>
+                    <a:bodyPr/>
+                    <a:lstStyle/>
+                    <a:p>
+                      <a:pPr algn="r"/>
+                      <a:r>
+                        <a:rPr sz="1100" b="1">
+                          <a:solidFill>
+                            <a:srgbClr val="FFFFFF"/>
+                          </a:solidFill>
+                          <a:latin typeface="Arial"/>
+                        </a:rPr>
+                        <a:t>FY 2027</a:t>
+                      </a:r>
+                    </a:p>
+                  </a:txBody>
+                  <a:tcPr>
+                    <a:solidFill>
+                      <a:srgbClr val="22424B"/>
+                    </a:solidFill>
+                  </a:tcPr>
+                </a:tc>
+              </a:tr>
+              <a:tr h="548640">
+                <a:tc>
+                  <a:txBody>
+                    <a:bodyPr/>
+                    <a:lstStyle/>
+                    <a:p>
+                      <a:r>
+                        <a:rPr sz="1250" b="0">
+                          <a:solidFill>
+                            <a:srgbClr val="3F4A4E"/>
+                          </a:solidFill>
+                          <a:latin typeface="Arial"/>
+                        </a:rPr>
+                        <a:t>Revenue</a:t>
+                      </a:r>
+                    </a:p>
+                  </a:txBody>
+                  <a:tcPr>
+                    <a:solidFill>
+                      <a:srgbClr val="F7F6F2"/>
+                    </a:solidFill>
+                  </a:tcPr>
+                </a:tc>
+                <a:tc>
+                  <a:txBody>
+                    <a:bodyPr/>
+                    <a:lstStyle/>
+                    <a:p>
+                      <a:pPr algn="r"/>
+                      <a:r>
+                        <a:rPr sz="1250" b="0">
+                          <a:solidFill>
+                            <a:srgbClr val="3F4A4E"/>
+                          </a:solidFill>
+                          <a:latin typeface="Arial"/>
+                        </a:rPr>
+                        <a:t>80.2</a:t>
+                      </a:r>
+                    </a:p>
+                  </a:txBody>
+                  <a:tcPr>
+                    <a:solidFill>
+                      <a:srgbClr val="F7F6F2"/>
+                    </a:solidFill>
+                  </a:tcPr>
+                </a:tc>
+                <a:tc>
+                  <a:txBody>
+                    <a:bodyPr/>
+                    <a:lstStyle/>
+                    <a:p>
+                      <a:pPr algn="r"/>
+                      <a:r>
+                        <a:rPr sz="1250" b="0">
+                          <a:solidFill>
+                            <a:srgbClr val="3F4A4E"/>
+                          </a:solidFill>
+                          <a:latin typeface="Arial"/>
+                        </a:rPr>
+                        <a:t>45.2</a:t>
+                      </a:r>
+                    </a:p>
+                  </a:txBody>
+                  <a:tcPr>
+                    <a:solidFill>
+                      <a:srgbClr val="F7F6F2"/>
+                    </a:solidFill>
+                  </a:tcPr>
+                </a:tc>
+                <a:tc>
+                  <a:txBody>
+                    <a:bodyPr/>
+                    <a:lstStyle/>
+                    <a:p>
+                      <a:pPr algn="r"/>
+                      <a:r>
+                        <a:rPr sz="1250" b="0">
+                          <a:solidFill>
+                            <a:srgbClr val="3F4A4E"/>
+                          </a:solidFill>
+                          <a:latin typeface="Arial"/>
+                        </a:rPr>
+                        <a:t>80.2</a:t>
+                      </a:r>
+                    </a:p>
+                  </a:txBody>
+                  <a:tcPr>
+                    <a:solidFill>
+                      <a:srgbClr val="F7F6F2"/>
+                    </a:solidFill>
+                  </a:tcPr>
+                </a:tc>
+                <a:tc>
+                  <a:txBody>
+                    <a:bodyPr/>
+                    <a:lstStyle/>
+                    <a:p>
+                      <a:pPr algn="r"/>
+                      <a:r>
+                        <a:rPr sz="1250" b="0">
+                          <a:solidFill>
+                            <a:srgbClr val="3F4A4E"/>
+                          </a:solidFill>
+                          <a:latin typeface="Arial"/>
+                        </a:rPr>
+                        <a:t>45.2</a:t>
+                      </a:r>
+                    </a:p>
+                  </a:txBody>
+                  <a:tcPr>
+                    <a:solidFill>
+                      <a:srgbClr val="F7F6F2"/>
+                    </a:solidFill>
+                  </a:tcPr>
+                </a:tc>
+                <a:tc>
+                  <a:txBody>
+                    <a:bodyPr/>
+                    <a:lstStyle/>
+                    <a:p>
+                      <a:pPr algn="r"/>
+                      <a:r>
+                        <a:rPr sz="1250" b="0">
+                          <a:solidFill>
+                            <a:srgbClr val="3F4A4E"/>
+                          </a:solidFill>
+                          <a:latin typeface="Arial"/>
+                        </a:rPr>
+                        <a:t>70.2</a:t>
+                      </a:r>
+                    </a:p>
+                  </a:txBody>
+                  <a:tcPr>
+                    <a:solidFill>
+                      <a:srgbClr val="F7F6F2"/>
+                    </a:solidFill>
+                  </a:tcPr>
+                </a:tc>
+                <a:tc>
+                  <a:txBody>
+                    <a:bodyPr/>
+                    <a:lstStyle/>
+                    <a:p>
+                      <a:pPr algn="r"/>
+                      <a:r>
+                        <a:rPr sz="1250" b="0">
+                          <a:solidFill>
+                            <a:srgbClr val="3F4A4E"/>
+                          </a:solidFill>
+                          <a:latin typeface="Arial"/>
+                        </a:rPr>
+                        <a:t>65.2</a:t>
+                      </a:r>
+                    </a:p>
+                  </a:txBody>
+                  <a:tcPr>
+                    <a:solidFill>
+                      <a:srgbClr val="F7F6F2"/>
+                    </a:solidFill>
+                  </a:tcPr>
+                </a:tc>
+                <a:tc>
+                  <a:txBody>
+                    <a:bodyPr/>
+                    <a:lstStyle/>
+                    <a:p>
+                      <a:pPr algn="r"/>
+                      <a:r>
+                        <a:rPr sz="1250" b="0">
+                          <a:solidFill>
+                            <a:srgbClr val="3F4A4E"/>
+                          </a:solidFill>
+                          <a:latin typeface="Arial"/>
+                        </a:rPr>
+                        <a:t>65.2</a:t>
+                      </a:r>
+                    </a:p>
+                  </a:txBody>
+                  <a:tcPr>
+                    <a:solidFill>
+                      <a:srgbClr val="F7F6F2"/>
+                    </a:solidFill>
+                  </a:tcPr>
+                </a:tc>
+                <a:tc>
+                  <a:txBody>
+                    <a:bodyPr/>
+                    <a:lstStyle/>
+                    <a:p>
+                      <a:pPr algn="r"/>
+                      <a:r>
+                        <a:rPr sz="1250" b="0">
+                          <a:solidFill>
+                            <a:srgbClr val="3F4A4E"/>
+                          </a:solidFill>
+                          <a:latin typeface="Arial"/>
+                        </a:rPr>
+                        <a:t>65.2</a:t>
+                      </a:r>
+                    </a:p>
+                  </a:txBody>
+                  <a:tcPr>
+                    <a:solidFill>
+                      <a:srgbClr val="F7F6F2"/>
+                    </a:solidFill>
+                  </a:tcPr>
+                </a:tc>
+                <a:tc>
+                  <a:txBody>
+                    <a:bodyPr/>
+                    <a:lstStyle/>
+                    <a:p>
+                      <a:pPr algn="r"/>
+                      <a:r>
+                        <a:rPr sz="1250" b="0">
+                          <a:solidFill>
+                            <a:srgbClr val="3F4A4E"/>
+                          </a:solidFill>
+                          <a:latin typeface="Arial"/>
+                        </a:rPr>
+                        <a:t>65.2</a:t>
+                      </a:r>
+                    </a:p>
+                  </a:txBody>
+                  <a:tcPr>
+                    <a:solidFill>
+                      <a:srgbClr val="F7F6F2"/>
+                    </a:solidFill>
+                  </a:tcPr>
+                </a:tc>
+                <a:tc>
+                  <a:txBody>
+                    <a:bodyPr/>
+                    <a:lstStyle/>
+                    <a:p>
+                      <a:pPr algn="r"/>
+                      <a:r>
+                        <a:rPr sz="1250" b="0">
+                          <a:solidFill>
+                            <a:srgbClr val="3F4A4E"/>
+                          </a:solidFill>
+                          <a:latin typeface="Arial"/>
+                        </a:rPr>
+                        <a:t>65.2</a:t>
+                      </a:r>
+                    </a:p>
+                  </a:txBody>
+                  <a:tcPr>
+                    <a:solidFill>
+                      <a:srgbClr val="F7F6F2"/>
+                    </a:solidFill>
+                  </a:tcPr>
+                </a:tc>
+                <a:tc>
+                  <a:txBody>
+                    <a:bodyPr/>
+                    <a:lstStyle/>
+                    <a:p>
+                      <a:pPr algn="r"/>
+                      <a:r>
+                        <a:rPr sz="1250" b="0">
+                          <a:solidFill>
+                            <a:srgbClr val="3F4A4E"/>
+                          </a:solidFill>
+                          <a:latin typeface="Arial"/>
+                        </a:rPr>
+                        <a:t>65.2</a:t>
+                      </a:r>
+                    </a:p>
+                  </a:txBody>
+                  <a:tcPr>
+                    <a:solidFill>
+                      <a:srgbClr val="F7F6F2"/>
+                    </a:solidFill>
+                  </a:tcPr>
+                </a:tc>
+                <a:tc>
+                  <a:txBody>
+                    <a:bodyPr/>
+                    <a:lstStyle/>
+                    <a:p>
+                      <a:pPr algn="r"/>
+                      <a:r>
+                        <a:rPr sz="1250" b="0">
+                          <a:solidFill>
+                            <a:srgbClr val="3F4A4E"/>
+                          </a:solidFill>
+                          <a:latin typeface="Arial"/>
+                        </a:rPr>
+                        <a:t>65.2</a:t>
+                      </a:r>
+                    </a:p>
+                  </a:txBody>
+                  <a:tcPr>
+                    <a:solidFill>
+                      <a:srgbClr val="F7F6F2"/>
+                    </a:solidFill>
+                  </a:tcPr>
+                </a:tc>
+                <a:tc>
+                  <a:txBody>
+                    <a:bodyPr/>
+                    <a:lstStyle/>
+                    <a:p>
+                      <a:pPr algn="r"/>
+                      <a:r>
+                        <a:rPr sz="1250" b="1">
+                          <a:solidFill>
+                            <a:srgbClr val="3F4A4E"/>
+                          </a:solidFill>
+                          <a:latin typeface="Arial"/>
+                        </a:rPr>
+                        <a:t>777.1</a:t>
+                      </a:r>
+                    </a:p>
+                  </a:txBody>
+                  <a:tcPr>
+                    <a:solidFill>
+                      <a:srgbClr val="F7F6F2"/>
+                    </a:solidFill>
+                  </a:tcPr>
+                </a:tc>
+              </a:tr>
+              <a:tr h="548640">
+                <a:tc>
+                  <a:txBody>
+                    <a:bodyPr/>
+                    <a:lstStyle/>
+                    <a:p>
+                      <a:r>
+                        <a:rPr sz="1250" b="0">
+                          <a:solidFill>
+                            <a:srgbClr val="3F4A4E"/>
+                          </a:solidFill>
+                          <a:latin typeface="Arial"/>
+                        </a:rPr>
+                        <a:t>Cost of goods</a:t>
+                      </a:r>
+                    </a:p>
+                  </a:txBody>
+                  <a:tcPr>
+                    <a:solidFill>
+                      <a:srgbClr val="FFFFFF"/>
+                    </a:solidFill>
+                  </a:tcPr>
+                </a:tc>
+                <a:tc>
+                  <a:txBody>
+                    <a:bodyPr/>
+                    <a:lstStyle/>
+                    <a:p>
+                      <a:pPr algn="r"/>
+                      <a:r>
+                        <a:rPr sz="1250" b="0">
+                          <a:solidFill>
+                            <a:srgbClr val="3F4A4E"/>
+                          </a:solidFill>
+                          <a:latin typeface="Arial"/>
+                        </a:rPr>
+                        <a:t>31.7</a:t>
+                      </a:r>
+                    </a:p>
+                  </a:txBody>
+                  <a:tcPr>
+                    <a:solidFill>
+                      <a:srgbClr val="FFFFFF"/>
+                    </a:solidFill>
+                  </a:tcPr>
+                </a:tc>
+                <a:tc>
+                  <a:txBody>
+                    <a:bodyPr/>
+                    <a:lstStyle/>
+                    <a:p>
+                      <a:pPr algn="r"/>
+                      <a:r>
+                        <a:rPr sz="1250" b="0">
+                          <a:solidFill>
+                            <a:srgbClr val="3F4A4E"/>
+                          </a:solidFill>
+                          <a:latin typeface="Arial"/>
+                        </a:rPr>
+                        <a:t>17.3</a:t>
+                      </a:r>
+                    </a:p>
+                  </a:txBody>
+                  <a:tcPr>
+                    <a:solidFill>
+                      <a:srgbClr val="FFFFFF"/>
+                    </a:solidFill>
+                  </a:tcPr>
+                </a:tc>
+                <a:tc>
+                  <a:txBody>
+                    <a:bodyPr/>
+                    <a:lstStyle/>
+                    <a:p>
+                      <a:pPr algn="r"/>
+                      <a:r>
+                        <a:rPr sz="1250" b="0">
+                          <a:solidFill>
+                            <a:srgbClr val="3F4A4E"/>
+                          </a:solidFill>
+                          <a:latin typeface="Arial"/>
+                        </a:rPr>
+                        <a:t>31.7</a:t>
+                      </a:r>
+                    </a:p>
+                  </a:txBody>
+                  <a:tcPr>
+                    <a:solidFill>
+                      <a:srgbClr val="FFFFFF"/>
+                    </a:solidFill>
+                  </a:tcPr>
+                </a:tc>
+                <a:tc>
+                  <a:txBody>
+                    <a:bodyPr/>
+                    <a:lstStyle/>
+                    <a:p>
+                      <a:pPr algn="r"/>
+                      <a:r>
+                        <a:rPr sz="1250" b="0">
+                          <a:solidFill>
+                            <a:srgbClr val="3F4A4E"/>
+                          </a:solidFill>
+                          <a:latin typeface="Arial"/>
+                        </a:rPr>
+                        <a:t>17.3</a:t>
+                      </a:r>
+                    </a:p>
+                  </a:txBody>
+                  <a:tcPr>
+                    <a:solidFill>
+                      <a:srgbClr val="FFFFFF"/>
+                    </a:solidFill>
+                  </a:tcPr>
+                </a:tc>
+                <a:tc>
+                  <a:txBody>
+                    <a:bodyPr/>
+                    <a:lstStyle/>
+                    <a:p>
+                      <a:pPr algn="r"/>
+                      <a:r>
+                        <a:rPr sz="1250" b="0">
+                          <a:solidFill>
+                            <a:srgbClr val="3F4A4E"/>
+                          </a:solidFill>
+                          <a:latin typeface="Arial"/>
+                        </a:rPr>
+                        <a:t>27.6</a:t>
+                      </a:r>
+                    </a:p>
+                  </a:txBody>
+                  <a:tcPr>
+                    <a:solidFill>
+                      <a:srgbClr val="FFFFFF"/>
+                    </a:solidFill>
+                  </a:tcPr>
+                </a:tc>
+                <a:tc>
+                  <a:txBody>
+                    <a:bodyPr/>
+                    <a:lstStyle/>
+                    <a:p>
+                      <a:pPr algn="r"/>
+                      <a:r>
+                        <a:rPr sz="1250" b="0">
+                          <a:solidFill>
+                            <a:srgbClr val="3F4A4E"/>
+                          </a:solidFill>
+                          <a:latin typeface="Arial"/>
+                        </a:rPr>
+                        <a:t>25.5</a:t>
+                      </a:r>
+                    </a:p>
+                  </a:txBody>
+                  <a:tcPr>
+                    <a:solidFill>
+                      <a:srgbClr val="FFFFFF"/>
+                    </a:solidFill>
+                  </a:tcPr>
+                </a:tc>
+                <a:tc>
+                  <a:txBody>
+                    <a:bodyPr/>
+                    <a:lstStyle/>
+                    <a:p>
+                      <a:pPr algn="r"/>
+                      <a:r>
+                        <a:rPr sz="1250" b="0">
+                          <a:solidFill>
+                            <a:srgbClr val="3F4A4E"/>
+                          </a:solidFill>
+                          <a:latin typeface="Arial"/>
+                        </a:rPr>
+                        <a:t>25.5</a:t>
+                      </a:r>
+                    </a:p>
+                  </a:txBody>
+                  <a:tcPr>
+                    <a:solidFill>
+                      <a:srgbClr val="FFFFFF"/>
+                    </a:solidFill>
+                  </a:tcPr>
+                </a:tc>
+                <a:tc>
+                  <a:txBody>
+                    <a:bodyPr/>
+                    <a:lstStyle/>
+                    <a:p>
+                      <a:pPr algn="r"/>
+                      <a:r>
+                        <a:rPr sz="1250" b="0">
+                          <a:solidFill>
+                            <a:srgbClr val="3F4A4E"/>
+                          </a:solidFill>
+                          <a:latin typeface="Arial"/>
+                        </a:rPr>
+                        <a:t>25.5</a:t>
+                      </a:r>
+                    </a:p>
+                  </a:txBody>
+                  <a:tcPr>
+                    <a:solidFill>
+                      <a:srgbClr val="FFFFFF"/>
+                    </a:solidFill>
+                  </a:tcPr>
+                </a:tc>
+                <a:tc>
+                  <a:txBody>
+                    <a:bodyPr/>
+                    <a:lstStyle/>
+                    <a:p>
+                      <a:pPr algn="r"/>
+                      <a:r>
+                        <a:rPr sz="1250" b="0">
+                          <a:solidFill>
+                            <a:srgbClr val="3F4A4E"/>
+                          </a:solidFill>
+                          <a:latin typeface="Arial"/>
+                        </a:rPr>
+                        <a:t>25.5</a:t>
+                      </a:r>
+                    </a:p>
+                  </a:txBody>
+                  <a:tcPr>
+                    <a:solidFill>
+                      <a:srgbClr val="FFFFFF"/>
+                    </a:solidFill>
+                  </a:tcPr>
+                </a:tc>
+                <a:tc>
+                  <a:txBody>
+                    <a:bodyPr/>
+                    <a:lstStyle/>
+                    <a:p>
+                      <a:pPr algn="r"/>
+                      <a:r>
+                        <a:rPr sz="1250" b="0">
+                          <a:solidFill>
+                            <a:srgbClr val="3F4A4E"/>
+                          </a:solidFill>
+                          <a:latin typeface="Arial"/>
+                        </a:rPr>
+                        <a:t>25.5</a:t>
+                      </a:r>
+                    </a:p>
+                  </a:txBody>
+                  <a:tcPr>
+                    <a:solidFill>
+                      <a:srgbClr val="FFFFFF"/>
+                    </a:solidFill>
+                  </a:tcPr>
+                </a:tc>
+                <a:tc>
+                  <a:txBody>
+                    <a:bodyPr/>
+                    <a:lstStyle/>
+                    <a:p>
+                      <a:pPr algn="r"/>
+                      <a:r>
+                        <a:rPr sz="1250" b="0">
+                          <a:solidFill>
+                            <a:srgbClr val="3F4A4E"/>
+                          </a:solidFill>
+                          <a:latin typeface="Arial"/>
+                        </a:rPr>
+                        <a:t>25.5</a:t>
+                      </a:r>
+                    </a:p>
+                  </a:txBody>
+                  <a:tcPr>
+                    <a:solidFill>
+                      <a:srgbClr val="FFFFFF"/>
+                    </a:solidFill>
+                  </a:tcPr>
+                </a:tc>
+                <a:tc>
+                  <a:txBody>
+                    <a:bodyPr/>
+                    <a:lstStyle/>
+                    <a:p>
+                      <a:pPr algn="r"/>
+                      <a:r>
+                        <a:rPr sz="1250" b="0">
+                          <a:solidFill>
+                            <a:srgbClr val="3F4A4E"/>
+                          </a:solidFill>
+                          <a:latin typeface="Arial"/>
+                        </a:rPr>
+                        <a:t>25.5</a:t>
+                      </a:r>
+                    </a:p>
+                  </a:txBody>
+                  <a:tcPr>
+                    <a:solidFill>
+                      <a:srgbClr val="FFFFFF"/>
+                    </a:solidFill>
+                  </a:tcPr>
+                </a:tc>
+                <a:tc>
+                  <a:txBody>
+                    <a:bodyPr/>
+                    <a:lstStyle/>
+                    <a:p>
+                      <a:pPr algn="r"/>
+                      <a:r>
+                        <a:rPr sz="1250" b="1">
+                          <a:solidFill>
+                            <a:srgbClr val="3F4A4E"/>
+                          </a:solidFill>
+                          <a:latin typeface="Arial"/>
+                        </a:rPr>
+                        <a:t>304.4</a:t>
+                      </a:r>
+                    </a:p>
+                  </a:txBody>
+                  <a:tcPr>
+                    <a:solidFill>
+                      <a:srgbClr val="FFFFFF"/>
+                    </a:solidFill>
+                  </a:tcPr>
+                </a:tc>
+              </a:tr>
+              <a:tr h="548640">
+                <a:tc>
+                  <a:txBody>
+                    <a:bodyPr/>
+                    <a:lstStyle/>
+                    <a:p>
+                      <a:r>
+                        <a:rPr sz="1250" b="0">
+                          <a:solidFill>
+                            <a:srgbClr val="3F4A4E"/>
+                          </a:solidFill>
+                          <a:latin typeface="Arial"/>
+                        </a:rPr>
+                        <a:t>Labor cost</a:t>
+                      </a:r>
+                    </a:p>
+                  </a:txBody>
+                  <a:tcPr>
+                    <a:solidFill>
+                      <a:srgbClr val="F7F6F2"/>
+                    </a:solidFill>
+                  </a:tcPr>
+                </a:tc>
+                <a:tc>
+                  <a:txBody>
+                    <a:bodyPr/>
+                    <a:lstStyle/>
+                    <a:p>
+                      <a:pPr algn="r"/>
+                      <a:r>
+                        <a:rPr sz="1250" b="0">
+                          <a:solidFill>
+                            <a:srgbClr val="3F4A4E"/>
+                          </a:solidFill>
+                          <a:latin typeface="Arial"/>
+                        </a:rPr>
+                        <a:t>19.0</a:t>
+                      </a:r>
+                    </a:p>
+                  </a:txBody>
+                  <a:tcPr>
+                    <a:solidFill>
+                      <a:srgbClr val="F7F6F2"/>
+                    </a:solidFill>
+                  </a:tcPr>
+                </a:tc>
+                <a:tc>
+                  <a:txBody>
+                    <a:bodyPr/>
+                    <a:lstStyle/>
+                    <a:p>
+                      <a:pPr algn="r"/>
+                      <a:r>
+                        <a:rPr sz="1250" b="0">
+                          <a:solidFill>
+                            <a:srgbClr val="3F4A4E"/>
+                          </a:solidFill>
+                          <a:latin typeface="Arial"/>
+                        </a:rPr>
+                        <a:t>14.7</a:t>
+                      </a:r>
+                    </a:p>
+                  </a:txBody>
+                  <a:tcPr>
+                    <a:solidFill>
+                      <a:srgbClr val="F7F6F2"/>
+                    </a:solidFill>
+                  </a:tcPr>
+                </a:tc>
+                <a:tc>
+                  <a:txBody>
+                    <a:bodyPr/>
+                    <a:lstStyle/>
+                    <a:p>
+                      <a:pPr algn="r"/>
+                      <a:r>
+                        <a:rPr sz="1250" b="0">
+                          <a:solidFill>
+                            <a:srgbClr val="3F4A4E"/>
+                          </a:solidFill>
+                          <a:latin typeface="Arial"/>
+                        </a:rPr>
+                        <a:t>19.0</a:t>
+                      </a:r>
+                    </a:p>
+                  </a:txBody>
+                  <a:tcPr>
+                    <a:solidFill>
+                      <a:srgbClr val="F7F6F2"/>
+                    </a:solidFill>
+                  </a:tcPr>
+                </a:tc>
+                <a:tc>
+                  <a:txBody>
+                    <a:bodyPr/>
+                    <a:lstStyle/>
+                    <a:p>
+                      <a:pPr algn="r"/>
+                      <a:r>
+                        <a:rPr sz="1250" b="0">
+                          <a:solidFill>
+                            <a:srgbClr val="3F4A4E"/>
+                          </a:solidFill>
+                          <a:latin typeface="Arial"/>
+                        </a:rPr>
+                        <a:t>14.7</a:t>
+                      </a:r>
+                    </a:p>
+                  </a:txBody>
+                  <a:tcPr>
+                    <a:solidFill>
+                      <a:srgbClr val="F7F6F2"/>
+                    </a:solidFill>
+                  </a:tcPr>
+                </a:tc>
+                <a:tc>
+                  <a:txBody>
+                    <a:bodyPr/>
+                    <a:lstStyle/>
+                    <a:p>
+                      <a:pPr algn="r"/>
+                      <a:r>
+                        <a:rPr sz="1250" b="0">
+                          <a:solidFill>
+                            <a:srgbClr val="3F4A4E"/>
+                          </a:solidFill>
+                          <a:latin typeface="Arial"/>
+                        </a:rPr>
+                        <a:t>17.8</a:t>
+                      </a:r>
+                    </a:p>
+                  </a:txBody>
+                  <a:tcPr>
+                    <a:solidFill>
+                      <a:srgbClr val="F7F6F2"/>
+                    </a:solidFill>
+                  </a:tcPr>
+                </a:tc>
+                <a:tc>
+                  <a:txBody>
+                    <a:bodyPr/>
+                    <a:lstStyle/>
+                    <a:p>
+                      <a:pPr algn="r"/>
+                      <a:r>
+                        <a:rPr sz="1250" b="0">
+                          <a:solidFill>
+                            <a:srgbClr val="3F4A4E"/>
+                          </a:solidFill>
+                          <a:latin typeface="Arial"/>
+                        </a:rPr>
+                        <a:t>17.2</a:t>
+                      </a:r>
+                    </a:p>
+                  </a:txBody>
+                  <a:tcPr>
+                    <a:solidFill>
+                      <a:srgbClr val="F7F6F2"/>
+                    </a:solidFill>
+                  </a:tcPr>
+                </a:tc>
+                <a:tc>
+                  <a:txBody>
+                    <a:bodyPr/>
+                    <a:lstStyle/>
+                    <a:p>
+                      <a:pPr algn="r"/>
+                      <a:r>
+                        <a:rPr sz="1250" b="0">
+                          <a:solidFill>
+                            <a:srgbClr val="3F4A4E"/>
+                          </a:solidFill>
+                          <a:latin typeface="Arial"/>
+                        </a:rPr>
+                        <a:t>17.2</a:t>
+                      </a:r>
+                    </a:p>
+                  </a:txBody>
+                  <a:tcPr>
+                    <a:solidFill>
+                      <a:srgbClr val="F7F6F2"/>
+                    </a:solidFill>
+                  </a:tcPr>
+                </a:tc>
+                <a:tc>
+                  <a:txBody>
+                    <a:bodyPr/>
+                    <a:lstStyle/>
+                    <a:p>
+                      <a:pPr algn="r"/>
+                      <a:r>
+                        <a:rPr sz="1250" b="0">
+                          <a:solidFill>
+                            <a:srgbClr val="3F4A4E"/>
+                          </a:solidFill>
+                          <a:latin typeface="Arial"/>
+                        </a:rPr>
+                        <a:t>17.2</a:t>
+                      </a:r>
+                    </a:p>
+                  </a:txBody>
+                  <a:tcPr>
+                    <a:solidFill>
+                      <a:srgbClr val="F7F6F2"/>
+                    </a:solidFill>
+                  </a:tcPr>
+                </a:tc>
+                <a:tc>
+                  <a:txBody>
+                    <a:bodyPr/>
+                    <a:lstStyle/>
+                    <a:p>
+                      <a:pPr algn="r"/>
+                      <a:r>
+                        <a:rPr sz="1250" b="0">
+                          <a:solidFill>
+                            <a:srgbClr val="3F4A4E"/>
+                          </a:solidFill>
+                          <a:latin typeface="Arial"/>
+                        </a:rPr>
+                        <a:t>17.2</a:t>
+                      </a:r>
+                    </a:p>
+                  </a:txBody>
+                  <a:tcPr>
+                    <a:solidFill>
+                      <a:srgbClr val="F7F6F2"/>
+                    </a:solidFill>
+                  </a:tcPr>
+                </a:tc>
+                <a:tc>
+                  <a:txBody>
+                    <a:bodyPr/>
+                    <a:lstStyle/>
+                    <a:p>
+                      <a:pPr algn="r"/>
+                      <a:r>
+                        <a:rPr sz="1250" b="0">
+                          <a:solidFill>
+                            <a:srgbClr val="3F4A4E"/>
+                          </a:solidFill>
+                          <a:latin typeface="Arial"/>
+                        </a:rPr>
+                        <a:t>17.2</a:t>
+                      </a:r>
+                    </a:p>
+                  </a:txBody>
+                  <a:tcPr>
+                    <a:solidFill>
+                      <a:srgbClr val="F7F6F2"/>
+                    </a:solidFill>
+                  </a:tcPr>
+                </a:tc>
+                <a:tc>
+                  <a:txBody>
+                    <a:bodyPr/>
+                    <a:lstStyle/>
+                    <a:p>
+                      <a:pPr algn="r"/>
+                      <a:r>
+                        <a:rPr sz="1250" b="0">
+                          <a:solidFill>
+                            <a:srgbClr val="3F4A4E"/>
+                          </a:solidFill>
+                          <a:latin typeface="Arial"/>
+                        </a:rPr>
+                        <a:t>17.2</a:t>
+                      </a:r>
+                    </a:p>
+                  </a:txBody>
+                  <a:tcPr>
+                    <a:solidFill>
+                      <a:srgbClr val="F7F6F2"/>
+                    </a:solidFill>
+                  </a:tcPr>
+                </a:tc>
+                <a:tc>
+                  <a:txBody>
+                    <a:bodyPr/>
+                    <a:lstStyle/>
+                    <a:p>
+                      <a:pPr algn="r"/>
+                      <a:r>
+                        <a:rPr sz="1250" b="0">
+                          <a:solidFill>
+                            <a:srgbClr val="3F4A4E"/>
+                          </a:solidFill>
+                          <a:latin typeface="Arial"/>
+                        </a:rPr>
+                        <a:t>13.4</a:t>
+                      </a:r>
+                    </a:p>
+                  </a:txBody>
+                  <a:tcPr>
+                    <a:solidFill>
+                      <a:srgbClr val="F7F6F2"/>
+                    </a:solidFill>
+                  </a:tcPr>
+                </a:tc>
+                <a:tc>
+                  <a:txBody>
+                    <a:bodyPr/>
+                    <a:lstStyle/>
+                    <a:p>
+                      <a:pPr algn="r"/>
+                      <a:r>
+                        <a:rPr sz="1250" b="1">
+                          <a:solidFill>
+                            <a:srgbClr val="3F4A4E"/>
+                          </a:solidFill>
+                          <a:latin typeface="Arial"/>
+                        </a:rPr>
+                        <a:t>201.8</a:t>
+                      </a:r>
+                    </a:p>
+                  </a:txBody>
+                  <a:tcPr>
+                    <a:solidFill>
+                      <a:srgbClr val="F7F6F2"/>
+                    </a:solidFill>
+                  </a:tcPr>
+                </a:tc>
+              </a:tr>
+              <a:tr h="548640">
+                <a:tc>
+                  <a:txBody>
+                    <a:bodyPr/>
+                    <a:lstStyle/>
+                    <a:p>
+                      <a:r>
+                        <a:rPr sz="1250" b="1">
+                          <a:solidFill>
+                            <a:srgbClr val="22424B"/>
+                          </a:solidFill>
+                          <a:latin typeface="Arial"/>
+                        </a:rPr>
+                        <a:t>Prime cost</a:t>
+                      </a:r>
+                    </a:p>
+                  </a:txBody>
+                  <a:tcPr>
+                    <a:solidFill>
+                      <a:srgbClr val="FFFFFF"/>
+                    </a:solidFill>
+                  </a:tcPr>
+                </a:tc>
+                <a:tc>
+                  <a:txBody>
+                    <a:bodyPr/>
+                    <a:lstStyle/>
+                    <a:p>
+                      <a:pPr algn="r"/>
+                      <a:r>
+                        <a:rPr sz="1250" b="1">
+                          <a:solidFill>
+                            <a:srgbClr val="22424B"/>
+                          </a:solidFill>
+                          <a:latin typeface="Arial"/>
+                        </a:rPr>
+                        <a:t>50.7</a:t>
+                      </a:r>
+                    </a:p>
+                  </a:txBody>
+                  <a:tcPr>
+                    <a:solidFill>
+                      <a:srgbClr val="FFFFFF"/>
+                    </a:solidFill>
+                  </a:tcPr>
+                </a:tc>
+                <a:tc>
+                  <a:txBody>
+                    <a:bodyPr/>
+                    <a:lstStyle/>
+                    <a:p>
+                      <a:pPr algn="r"/>
+                      <a:r>
+                        <a:rPr sz="1250" b="1">
+                          <a:solidFill>
+                            <a:srgbClr val="22424B"/>
+                          </a:solidFill>
+                          <a:latin typeface="Arial"/>
+                        </a:rPr>
+                        <a:t>32.1</a:t>
+                      </a:r>
+                    </a:p>
+                  </a:txBody>
+                  <a:tcPr>
+                    <a:solidFill>
+                      <a:srgbClr val="FFFFFF"/>
+                    </a:solidFill>
+                  </a:tcPr>
+                </a:tc>
+                <a:tc>
+                  <a:txBody>
+                    <a:bodyPr/>
+                    <a:lstStyle/>
+                    <a:p>
+                      <a:pPr algn="r"/>
+                      <a:r>
+                        <a:rPr sz="1250" b="1">
+                          <a:solidFill>
+                            <a:srgbClr val="22424B"/>
+                          </a:solidFill>
+                          <a:latin typeface="Arial"/>
+                        </a:rPr>
+                        <a:t>50.7</a:t>
+                      </a:r>
+                    </a:p>
+                  </a:txBody>
+                  <a:tcPr>
+                    <a:solidFill>
+                      <a:srgbClr val="FFFFFF"/>
+                    </a:solidFill>
+                  </a:tcPr>
+                </a:tc>
+                <a:tc>
+                  <a:txBody>
+                    <a:bodyPr/>
+                    <a:lstStyle/>
+                    <a:p>
+                      <a:pPr algn="r"/>
+                      <a:r>
+                        <a:rPr sz="1250" b="1">
+                          <a:solidFill>
+                            <a:srgbClr val="22424B"/>
+                          </a:solidFill>
+                          <a:latin typeface="Arial"/>
+                        </a:rPr>
+                        <a:t>32.1</a:t>
+                      </a:r>
+                    </a:p>
+                  </a:txBody>
+                  <a:tcPr>
+                    <a:solidFill>
+                      <a:srgbClr val="FFFFFF"/>
+                    </a:solidFill>
+                  </a:tcPr>
+                </a:tc>
+                <a:tc>
+                  <a:txBody>
+                    <a:bodyPr/>
+                    <a:lstStyle/>
+                    <a:p>
+                      <a:pPr algn="r"/>
+                      <a:r>
+                        <a:rPr sz="1250" b="1">
+                          <a:solidFill>
+                            <a:srgbClr val="22424B"/>
+                          </a:solidFill>
+                          <a:latin typeface="Arial"/>
+                        </a:rPr>
+                        <a:t>45.4</a:t>
+                      </a:r>
+                    </a:p>
+                  </a:txBody>
+                  <a:tcPr>
+                    <a:solidFill>
+                      <a:srgbClr val="FFFFFF"/>
+                    </a:solidFill>
+                  </a:tcPr>
+                </a:tc>
+                <a:tc>
+                  <a:txBody>
+                    <a:bodyPr/>
+                    <a:lstStyle/>
+                    <a:p>
+                      <a:pPr algn="r"/>
+                      <a:r>
+                        <a:rPr sz="1250" b="1">
+                          <a:solidFill>
+                            <a:srgbClr val="22424B"/>
+                          </a:solidFill>
+                          <a:latin typeface="Arial"/>
+                        </a:rPr>
+                        <a:t>42.7</a:t>
+                      </a:r>
+                    </a:p>
+                  </a:txBody>
+                  <a:tcPr>
+                    <a:solidFill>
+                      <a:srgbClr val="FFFFFF"/>
+                    </a:solidFill>
+                  </a:tcPr>
+                </a:tc>
+                <a:tc>
+                  <a:txBody>
+                    <a:bodyPr/>
+                    <a:lstStyle/>
+                    <a:p>
+                      <a:pPr algn="r"/>
+                      <a:r>
+                        <a:rPr sz="1250" b="1">
+                          <a:solidFill>
+                            <a:srgbClr val="22424B"/>
+                          </a:solidFill>
+                          <a:latin typeface="Arial"/>
+                        </a:rPr>
+                        <a:t>42.7</a:t>
+                      </a:r>
+                    </a:p>
+                  </a:txBody>
+                  <a:tcPr>
+                    <a:solidFill>
+                      <a:srgbClr val="FFFFFF"/>
+                    </a:solidFill>
+                  </a:tcPr>
+                </a:tc>
+                <a:tc>
+                  <a:txBody>
+                    <a:bodyPr/>
+                    <a:lstStyle/>
+                    <a:p>
+                      <a:pPr algn="r"/>
+                      <a:r>
+                        <a:rPr sz="1250" b="1">
+                          <a:solidFill>
+                            <a:srgbClr val="22424B"/>
+                          </a:solidFill>
+                          <a:latin typeface="Arial"/>
+                        </a:rPr>
+                        <a:t>42.7</a:t>
+                      </a:r>
+                    </a:p>
+                  </a:txBody>
+                  <a:tcPr>
+                    <a:solidFill>
+                      <a:srgbClr val="FFFFFF"/>
+                    </a:solidFill>
+                  </a:tcPr>
+                </a:tc>
+                <a:tc>
+                  <a:txBody>
+                    <a:bodyPr/>
+                    <a:lstStyle/>
+                    <a:p>
+                      <a:pPr algn="r"/>
+                      <a:r>
+                        <a:rPr sz="1250" b="1">
+                          <a:solidFill>
+                            <a:srgbClr val="22424B"/>
+                          </a:solidFill>
+                          <a:latin typeface="Arial"/>
+                        </a:rPr>
+                        <a:t>42.7</a:t>
+                      </a:r>
+                    </a:p>
+                  </a:txBody>
+                  <a:tcPr>
+                    <a:solidFill>
+                      <a:srgbClr val="FFFFFF"/>
+                    </a:solidFill>
+                  </a:tcPr>
+                </a:tc>
+                <a:tc>
+                  <a:txBody>
+                    <a:bodyPr/>
+                    <a:lstStyle/>
+                    <a:p>
+                      <a:pPr algn="r"/>
+                      <a:r>
+                        <a:rPr sz="1250" b="1">
+                          <a:solidFill>
+                            <a:srgbClr val="22424B"/>
+                          </a:solidFill>
+                          <a:latin typeface="Arial"/>
+                        </a:rPr>
+                        <a:t>42.7</a:t>
+                      </a:r>
+                    </a:p>
+                  </a:txBody>
+                  <a:tcPr>
+                    <a:solidFill>
+                      <a:srgbClr val="FFFFFF"/>
+                    </a:solidFill>
+                  </a:tcPr>
+                </a:tc>
+                <a:tc>
+                  <a:txBody>
+                    <a:bodyPr/>
+                    <a:lstStyle/>
+                    <a:p>
+                      <a:pPr algn="r"/>
+                      <a:r>
+                        <a:rPr sz="1250" b="1">
+                          <a:solidFill>
+                            <a:srgbClr val="22424B"/>
+                          </a:solidFill>
+                          <a:latin typeface="Arial"/>
+                        </a:rPr>
+                        <a:t>42.7</a:t>
+                      </a:r>
+                    </a:p>
+                  </a:txBody>
+                  <a:tcPr>
+                    <a:solidFill>
+                      <a:srgbClr val="FFFFFF"/>
+                    </a:solidFill>
+                  </a:tcPr>
+                </a:tc>
+                <a:tc>
+                  <a:txBody>
+                    <a:bodyPr/>
+                    <a:lstStyle/>
+                    <a:p>
+                      <a:pPr algn="r"/>
+                      <a:r>
+                        <a:rPr sz="1250" b="1">
+                          <a:solidFill>
+                            <a:srgbClr val="22424B"/>
+                          </a:solidFill>
+                          <a:latin typeface="Arial"/>
+                        </a:rPr>
+                        <a:t>39.0</a:t>
+                      </a:r>
+                    </a:p>
+                  </a:txBody>
+                  <a:tcPr>
+                    <a:solidFill>
+                      <a:srgbClr val="FFFFFF"/>
+                    </a:solidFill>
+                  </a:tcPr>
+                </a:tc>
+                <a:tc>
+                  <a:txBody>
+                    <a:bodyPr/>
+                    <a:lstStyle/>
+                    <a:p>
+                      <a:pPr algn="r"/>
+                      <a:r>
+                        <a:rPr sz="1250" b="1">
+                          <a:solidFill>
+                            <a:srgbClr val="22424B"/>
+                          </a:solidFill>
+                          <a:latin typeface="Arial"/>
+                        </a:rPr>
+                        <a:t>506.3</a:t>
+                      </a:r>
+                    </a:p>
+                  </a:txBody>
+                  <a:tcPr>
+                    <a:solidFill>
+                      <a:srgbClr val="FFFFFF"/>
+                    </a:solidFill>
+                  </a:tcPr>
+                </a:tc>
+              </a:tr>
+              <a:tr h="548640">
+                <a:tc>
+                  <a:txBody>
+                    <a:bodyPr/>
+                    <a:lstStyle/>
+                    <a:p>
+                      <a:r>
+                        <a:rPr sz="1250" b="1">
+                          <a:solidFill>
+                            <a:srgbClr val="22424B"/>
+                          </a:solidFill>
+                          <a:latin typeface="Arial"/>
+                        </a:rPr>
+                        <a:t>Operating profit</a:t>
+                      </a:r>
+                    </a:p>
+                  </a:txBody>
+                  <a:tcPr>
+                    <a:solidFill>
+                      <a:srgbClr val="F7F6F2"/>
+                    </a:solidFill>
+                  </a:tcPr>
+                </a:tc>
+                <a:tc>
+                  <a:txBody>
+                    <a:bodyPr/>
+                    <a:lstStyle/>
+                    <a:p>
+                      <a:pPr algn="r"/>
+                      <a:r>
+                        <a:rPr sz="1250" b="1">
+                          <a:solidFill>
+                            <a:srgbClr val="22424B"/>
+                          </a:solidFill>
+                          <a:latin typeface="Arial"/>
+                        </a:rPr>
+                        <a:t>29.5</a:t>
+                      </a:r>
+                    </a:p>
+                  </a:txBody>
+                  <a:tcPr>
+                    <a:solidFill>
+                      <a:srgbClr val="F7F6F2"/>
+                    </a:solidFill>
+                  </a:tcPr>
+                </a:tc>
+                <a:tc>
+                  <a:txBody>
+                    <a:bodyPr/>
+                    <a:lstStyle/>
+                    <a:p>
+                      <a:pPr algn="r"/>
+                      <a:r>
+                        <a:rPr sz="1250" b="1">
+                          <a:solidFill>
+                            <a:srgbClr val="22424B"/>
+                          </a:solidFill>
+                          <a:latin typeface="Arial"/>
+                        </a:rPr>
+                        <a:t>13.1</a:t>
+                      </a:r>
+                    </a:p>
+                  </a:txBody>
+                  <a:tcPr>
+                    <a:solidFill>
+                      <a:srgbClr val="F7F6F2"/>
+                    </a:solidFill>
+                  </a:tcPr>
+                </a:tc>
+                <a:tc>
+                  <a:txBody>
+                    <a:bodyPr/>
+                    <a:lstStyle/>
+                    <a:p>
+                      <a:pPr algn="r"/>
+                      <a:r>
+                        <a:rPr sz="1250" b="1">
+                          <a:solidFill>
+                            <a:srgbClr val="22424B"/>
+                          </a:solidFill>
+                          <a:latin typeface="Arial"/>
+                        </a:rPr>
+                        <a:t>29.5</a:t>
+                      </a:r>
+                    </a:p>
+                  </a:txBody>
+                  <a:tcPr>
+                    <a:solidFill>
+                      <a:srgbClr val="F7F6F2"/>
+                    </a:solidFill>
+                  </a:tcPr>
+                </a:tc>
+                <a:tc>
+                  <a:txBody>
+                    <a:bodyPr/>
+                    <a:lstStyle/>
+                    <a:p>
+                      <a:pPr algn="r"/>
+                      <a:r>
+                        <a:rPr sz="1250" b="1">
+                          <a:solidFill>
+                            <a:srgbClr val="22424B"/>
+                          </a:solidFill>
+                          <a:latin typeface="Arial"/>
+                        </a:rPr>
+                        <a:t>13.1</a:t>
+                      </a:r>
+                    </a:p>
+                  </a:txBody>
+                  <a:tcPr>
+                    <a:solidFill>
+                      <a:srgbClr val="F7F6F2"/>
+                    </a:solidFill>
+                  </a:tcPr>
+                </a:tc>
+                <a:tc>
+                  <a:txBody>
+                    <a:bodyPr/>
+                    <a:lstStyle/>
+                    <a:p>
+                      <a:pPr algn="r"/>
+                      <a:r>
+                        <a:rPr sz="1250" b="1">
+                          <a:solidFill>
+                            <a:srgbClr val="22424B"/>
+                          </a:solidFill>
+                          <a:latin typeface="Arial"/>
+                        </a:rPr>
+                        <a:t>24.8</a:t>
+                      </a:r>
+                    </a:p>
+                  </a:txBody>
+                  <a:tcPr>
+                    <a:solidFill>
+                      <a:srgbClr val="F7F6F2"/>
+                    </a:solidFill>
+                  </a:tcPr>
+                </a:tc>
+                <a:tc>
+                  <a:txBody>
+                    <a:bodyPr/>
+                    <a:lstStyle/>
+                    <a:p>
+                      <a:pPr algn="r"/>
+                      <a:r>
+                        <a:rPr sz="1250" b="1">
+                          <a:solidFill>
+                            <a:srgbClr val="22424B"/>
+                          </a:solidFill>
+                          <a:latin typeface="Arial"/>
+                        </a:rPr>
+                        <a:t>22.4</a:t>
+                      </a:r>
+                    </a:p>
+                  </a:txBody>
+                  <a:tcPr>
+                    <a:solidFill>
+                      <a:srgbClr val="F7F6F2"/>
+                    </a:solidFill>
+                  </a:tcPr>
+                </a:tc>
+                <a:tc>
+                  <a:txBody>
+                    <a:bodyPr/>
+                    <a:lstStyle/>
+                    <a:p>
+                      <a:pPr algn="r"/>
+                      <a:r>
+                        <a:rPr sz="1250" b="1">
+                          <a:solidFill>
+                            <a:srgbClr val="22424B"/>
+                          </a:solidFill>
+                          <a:latin typeface="Arial"/>
+                        </a:rPr>
+                        <a:t>22.4</a:t>
+                      </a:r>
+                    </a:p>
+                  </a:txBody>
+                  <a:tcPr>
+                    <a:solidFill>
+                      <a:srgbClr val="F7F6F2"/>
+                    </a:solidFill>
+                  </a:tcPr>
+                </a:tc>
+                <a:tc>
+                  <a:txBody>
+                    <a:bodyPr/>
+                    <a:lstStyle/>
+                    <a:p>
+                      <a:pPr algn="r"/>
+                      <a:r>
+                        <a:rPr sz="1250" b="1">
+                          <a:solidFill>
+                            <a:srgbClr val="22424B"/>
+                          </a:solidFill>
+                          <a:latin typeface="Arial"/>
+                        </a:rPr>
+                        <a:t>22.4</a:t>
+                      </a:r>
+                    </a:p>
+                  </a:txBody>
+                  <a:tcPr>
+                    <a:solidFill>
+                      <a:srgbClr val="F7F6F2"/>
+                    </a:solidFill>
+                  </a:tcPr>
+                </a:tc>
+                <a:tc>
+                  <a:txBody>
+                    <a:bodyPr/>
+                    <a:lstStyle/>
+                    <a:p>
+                      <a:pPr algn="r"/>
+                      <a:r>
+                        <a:rPr sz="1250" b="1">
+                          <a:solidFill>
+                            <a:srgbClr val="22424B"/>
+                          </a:solidFill>
+                          <a:latin typeface="Arial"/>
+                        </a:rPr>
+                        <a:t>22.4</a:t>
+                      </a:r>
+                    </a:p>
+                  </a:txBody>
+                  <a:tcPr>
+                    <a:solidFill>
+                      <a:srgbClr val="F7F6F2"/>
+                    </a:solidFill>
+                  </a:tcPr>
+                </a:tc>
+                <a:tc>
+                  <a:txBody>
+                    <a:bodyPr/>
+                    <a:lstStyle/>
+                    <a:p>
+                      <a:pPr algn="r"/>
+                      <a:r>
+                        <a:rPr sz="1250" b="1">
+                          <a:solidFill>
+                            <a:srgbClr val="22424B"/>
+                          </a:solidFill>
+                          <a:latin typeface="Arial"/>
+                        </a:rPr>
+                        <a:t>22.4</a:t>
+                      </a:r>
+                    </a:p>
+                  </a:txBody>
+                  <a:tcPr>
+                    <a:solidFill>
+                      <a:srgbClr val="F7F6F2"/>
+                    </a:solidFill>
+                  </a:tcPr>
+                </a:tc>
+                <a:tc>
+                  <a:txBody>
+                    <a:bodyPr/>
+                    <a:lstStyle/>
+                    <a:p>
+                      <a:pPr algn="r"/>
+                      <a:r>
+                        <a:rPr sz="1250" b="1">
+                          <a:solidFill>
+                            <a:srgbClr val="22424B"/>
+                          </a:solidFill>
+                          <a:latin typeface="Arial"/>
+                        </a:rPr>
+                        <a:t>22.4</a:t>
+                      </a:r>
+                    </a:p>
+                  </a:txBody>
+                  <a:tcPr>
+                    <a:solidFill>
+                      <a:srgbClr val="F7F6F2"/>
+                    </a:solidFill>
+                  </a:tcPr>
+                </a:tc>
+                <a:tc>
+                  <a:txBody>
+                    <a:bodyPr/>
+                    <a:lstStyle/>
+                    <a:p>
+                      <a:pPr algn="r"/>
+                      <a:r>
+                        <a:rPr sz="1250" b="1">
+                          <a:solidFill>
+                            <a:srgbClr val="22424B"/>
+                          </a:solidFill>
+                          <a:latin typeface="Arial"/>
+                        </a:rPr>
+                        <a:t>26.2</a:t>
+                      </a:r>
+                    </a:p>
+                  </a:txBody>
+                  <a:tcPr>
+                    <a:solidFill>
+                      <a:srgbClr val="F7F6F2"/>
+                    </a:solidFill>
+                  </a:tcPr>
+                </a:tc>
+                <a:tc>
+                  <a:txBody>
+                    <a:bodyPr/>
+                    <a:lstStyle/>
+                    <a:p>
+                      <a:pPr algn="r"/>
+                      <a:r>
+                        <a:rPr sz="1250" b="1">
+                          <a:solidFill>
+                            <a:srgbClr val="22424B"/>
+                          </a:solidFill>
+                          <a:latin typeface="Arial"/>
+                        </a:rPr>
+                        <a:t>270.8</a:t>
+                      </a:r>
+                    </a:p>
+                  </a:txBody>
+                  <a:tcPr>
+                    <a:solidFill>
+                      <a:srgbClr val="F7F6F2"/>
+                    </a:solidFill>
+                  </a:tcPr>
+                </a:tc>
+              </a:tr>
+              <a:tr h="548640">
+                <a:tc>
+                  <a:txBody>
+                    <a:bodyPr/>
+                    <a:lstStyle/>
+                    <a:p>
+                      <a:r>
+                        <a:rPr sz="1250" b="0">
+                          <a:solidFill>
+                            <a:srgbClr val="3F4A4E"/>
+                          </a:solidFill>
+                          <a:latin typeface="Arial"/>
+                        </a:rPr>
+                        <a:t>Controllable expenses</a:t>
+                      </a:r>
+                    </a:p>
+                  </a:txBody>
+                  <a:tcPr>
+                    <a:solidFill>
+                      <a:srgbClr val="FFFFFF"/>
+                    </a:solidFill>
+                  </a:tcPr>
+                </a:tc>
+                <a:tc>
+                  <a:txBody>
+                    <a:bodyPr/>
+                    <a:lstStyle/>
+                    <a:p>
+                      <a:pPr algn="r"/>
+                      <a:r>
+                        <a:rPr sz="1250" b="0">
+                          <a:solidFill>
+                            <a:srgbClr val="3F4A4E"/>
+                          </a:solidFill>
+                          <a:latin typeface="Arial"/>
+                        </a:rPr>
+                        <a:t>14.3</a:t>
+                      </a:r>
+                    </a:p>
+                  </a:txBody>
+                  <a:tcPr>
+                    <a:solidFill>
+                      <a:srgbClr val="FFFFFF"/>
+                    </a:solidFill>
+                  </a:tcPr>
+                </a:tc>
+                <a:tc>
+                  <a:txBody>
+                    <a:bodyPr/>
+                    <a:lstStyle/>
+                    <a:p>
+                      <a:pPr algn="r"/>
+                      <a:r>
+                        <a:rPr sz="1250" b="0">
+                          <a:solidFill>
+                            <a:srgbClr val="3F4A4E"/>
+                          </a:solidFill>
+                          <a:latin typeface="Arial"/>
+                        </a:rPr>
+                        <a:t>10.9</a:t>
+                      </a:r>
+                    </a:p>
+                  </a:txBody>
+                  <a:tcPr>
+                    <a:solidFill>
+                      <a:srgbClr val="FFFFFF"/>
+                    </a:solidFill>
+                  </a:tcPr>
+                </a:tc>
+                <a:tc>
+                  <a:txBody>
+                    <a:bodyPr/>
+                    <a:lstStyle/>
+                    <a:p>
+                      <a:pPr algn="r"/>
+                      <a:r>
+                        <a:rPr sz="1250" b="0">
+                          <a:solidFill>
+                            <a:srgbClr val="3F4A4E"/>
+                          </a:solidFill>
+                          <a:latin typeface="Arial"/>
+                        </a:rPr>
+                        <a:t>14.3</a:t>
+                      </a:r>
+                    </a:p>
+                  </a:txBody>
+                  <a:tcPr>
+                    <a:solidFill>
+                      <a:srgbClr val="FFFFFF"/>
+                    </a:solidFill>
+                  </a:tcPr>
+                </a:tc>
+                <a:tc>
+                  <a:txBody>
+                    <a:bodyPr/>
+                    <a:lstStyle/>
+                    <a:p>
+                      <a:pPr algn="r"/>
+                      <a:r>
+                        <a:rPr sz="1250" b="0">
+                          <a:solidFill>
+                            <a:srgbClr val="3F4A4E"/>
+                          </a:solidFill>
+                          <a:latin typeface="Arial"/>
+                        </a:rPr>
+                        <a:t>10.9</a:t>
+                      </a:r>
+                    </a:p>
+                  </a:txBody>
+                  <a:tcPr>
+                    <a:solidFill>
+                      <a:srgbClr val="FFFFFF"/>
+                    </a:solidFill>
+                  </a:tcPr>
+                </a:tc>
+                <a:tc>
+                  <a:txBody>
+                    <a:bodyPr/>
+                    <a:lstStyle/>
+                    <a:p>
+                      <a:pPr algn="r"/>
+                      <a:r>
+                        <a:rPr sz="1250" b="0">
+                          <a:solidFill>
+                            <a:srgbClr val="3F4A4E"/>
+                          </a:solidFill>
+                          <a:latin typeface="Arial"/>
+                        </a:rPr>
+                        <a:t>13.3</a:t>
+                      </a:r>
+                    </a:p>
+                  </a:txBody>
+                  <a:tcPr>
+                    <a:solidFill>
+                      <a:srgbClr val="FFFFFF"/>
+                    </a:solidFill>
+                  </a:tcPr>
+                </a:tc>
+                <a:tc>
+                  <a:txBody>
+                    <a:bodyPr/>
+                    <a:lstStyle/>
+                    <a:p>
+                      <a:pPr algn="r"/>
+                      <a:r>
+                        <a:rPr sz="1250" b="0">
+                          <a:solidFill>
+                            <a:srgbClr val="3F4A4E"/>
+                          </a:solidFill>
+                          <a:latin typeface="Arial"/>
+                        </a:rPr>
+                        <a:t>12.8</a:t>
+                      </a:r>
+                    </a:p>
+                  </a:txBody>
+                  <a:tcPr>
+                    <a:solidFill>
+                      <a:srgbClr val="FFFFFF"/>
+                    </a:solidFill>
+                  </a:tcPr>
+                </a:tc>
+                <a:tc>
+                  <a:txBody>
+                    <a:bodyPr/>
+                    <a:lstStyle/>
+                    <a:p>
+                      <a:pPr algn="r"/>
+                      <a:r>
+                        <a:rPr sz="1250" b="0">
+                          <a:solidFill>
+                            <a:srgbClr val="3F4A4E"/>
+                          </a:solidFill>
+                          <a:latin typeface="Arial"/>
+                        </a:rPr>
+                        <a:t>12.8</a:t>
+                      </a:r>
+                    </a:p>
+                  </a:txBody>
+                  <a:tcPr>
+                    <a:solidFill>
+                      <a:srgbClr val="FFFFFF"/>
+                    </a:solidFill>
+                  </a:tcPr>
+                </a:tc>
+                <a:tc>
+                  <a:txBody>
+                    <a:bodyPr/>
+                    <a:lstStyle/>
+                    <a:p>
+                      <a:pPr algn="r"/>
+                      <a:r>
+                        <a:rPr sz="1250" b="0">
+                          <a:solidFill>
+                            <a:srgbClr val="3F4A4E"/>
+                          </a:solidFill>
+                          <a:latin typeface="Arial"/>
+                        </a:rPr>
+                        <a:t>12.8</a:t>
+                      </a:r>
+                    </a:p>
+                  </a:txBody>
+                  <a:tcPr>
+                    <a:solidFill>
+                      <a:srgbClr val="FFFFFF"/>
+                    </a:solidFill>
+                  </a:tcPr>
+                </a:tc>
+                <a:tc>
+                  <a:txBody>
+                    <a:bodyPr/>
+                    <a:lstStyle/>
+                    <a:p>
+                      <a:pPr algn="r"/>
+                      <a:r>
+                        <a:rPr sz="1250" b="0">
+                          <a:solidFill>
+                            <a:srgbClr val="3F4A4E"/>
+                          </a:solidFill>
+                          <a:latin typeface="Arial"/>
+                        </a:rPr>
+                        <a:t>12.8</a:t>
+                      </a:r>
+                    </a:p>
+                  </a:txBody>
+                  <a:tcPr>
+                    <a:solidFill>
+                      <a:srgbClr val="FFFFFF"/>
+                    </a:solidFill>
+                  </a:tcPr>
+                </a:tc>
+                <a:tc>
+                  <a:txBody>
+                    <a:bodyPr/>
+                    <a:lstStyle/>
+                    <a:p>
+                      <a:pPr algn="r"/>
+                      <a:r>
+                        <a:rPr sz="1250" b="0">
+                          <a:solidFill>
+                            <a:srgbClr val="3F4A4E"/>
+                          </a:solidFill>
+                          <a:latin typeface="Arial"/>
+                        </a:rPr>
+                        <a:t>12.8</a:t>
+                      </a:r>
+                    </a:p>
+                  </a:txBody>
+                  <a:tcPr>
+                    <a:solidFill>
+                      <a:srgbClr val="FFFFFF"/>
+                    </a:solidFill>
+                  </a:tcPr>
+                </a:tc>
+                <a:tc>
+                  <a:txBody>
+                    <a:bodyPr/>
+                    <a:lstStyle/>
+                    <a:p>
+                      <a:pPr algn="r"/>
+                      <a:r>
+                        <a:rPr sz="1250" b="0">
+                          <a:solidFill>
+                            <a:srgbClr val="3F4A4E"/>
+                          </a:solidFill>
+                          <a:latin typeface="Arial"/>
+                        </a:rPr>
+                        <a:t>12.8</a:t>
+                      </a:r>
+                    </a:p>
+                  </a:txBody>
+                  <a:tcPr>
+                    <a:solidFill>
+                      <a:srgbClr val="FFFFFF"/>
+                    </a:solidFill>
+                  </a:tcPr>
+                </a:tc>
+                <a:tc>
+                  <a:txBody>
+                    <a:bodyPr/>
+                    <a:lstStyle/>
+                    <a:p>
+                      <a:pPr algn="r"/>
+                      <a:r>
+                        <a:rPr sz="1250" b="0">
+                          <a:solidFill>
+                            <a:srgbClr val="3F4A4E"/>
+                          </a:solidFill>
+                          <a:latin typeface="Arial"/>
+                        </a:rPr>
+                        <a:t>12.8</a:t>
+                      </a:r>
+                    </a:p>
+                  </a:txBody>
+                  <a:tcPr>
+                    <a:solidFill>
+                      <a:srgbClr val="FFFFFF"/>
+                    </a:solidFill>
+                  </a:tcPr>
+                </a:tc>
+                <a:tc>
+                  <a:txBody>
+                    <a:bodyPr/>
+                    <a:lstStyle/>
+                    <a:p>
+                      <a:pPr algn="r"/>
+                      <a:r>
+                        <a:rPr sz="1250" b="1">
+                          <a:solidFill>
+                            <a:srgbClr val="3F4A4E"/>
+                          </a:solidFill>
+                          <a:latin typeface="Arial"/>
+                        </a:rPr>
+                        <a:t>153.4</a:t>
+                      </a:r>
+                    </a:p>
+                  </a:txBody>
+                  <a:tcPr>
+                    <a:solidFill>
+                      <a:srgbClr val="FFFFFF"/>
+                    </a:solidFill>
+                  </a:tcPr>
+                </a:tc>
+              </a:tr>
+              <a:tr h="548640">
+                <a:tc>
+                  <a:txBody>
+                    <a:bodyPr/>
+                    <a:lstStyle/>
+                    <a:p>
+                      <a:r>
+                        <a:rPr sz="1250" b="0">
+                          <a:solidFill>
+                            <a:srgbClr val="3F4A4E"/>
+                          </a:solidFill>
+                          <a:latin typeface="Arial"/>
+                        </a:rPr>
+                        <a:t>Uncontrollable expenses</a:t>
+                      </a:r>
+                    </a:p>
+                  </a:txBody>
+                  <a:tcPr>
+                    <a:solidFill>
+                      <a:srgbClr val="F7F6F2"/>
+                    </a:solidFill>
+                  </a:tcPr>
+                </a:tc>
+                <a:tc>
+                  <a:txBody>
+                    <a:bodyPr/>
+                    <a:lstStyle/>
+                    <a:p>
+                      <a:pPr algn="r"/>
+                      <a:r>
+                        <a:rPr sz="1250" b="0">
+                          <a:solidFill>
+                            <a:srgbClr val="3F4A4E"/>
+                          </a:solidFill>
+                          <a:latin typeface="Arial"/>
+                        </a:rPr>
+                        <a:t>6.1</a:t>
+                      </a:r>
+                    </a:p>
+                  </a:txBody>
+                  <a:tcPr>
+                    <a:solidFill>
+                      <a:srgbClr val="F7F6F2"/>
+                    </a:solidFill>
+                  </a:tcPr>
+                </a:tc>
+                <a:tc>
+                  <a:txBody>
+                    <a:bodyPr/>
+                    <a:lstStyle/>
+                    <a:p>
+                      <a:pPr algn="r"/>
+                      <a:r>
+                        <a:rPr sz="1250" b="0">
+                          <a:solidFill>
+                            <a:srgbClr val="3F4A4E"/>
+                          </a:solidFill>
+                          <a:latin typeface="Arial"/>
+                        </a:rPr>
+                        <a:t>4.7</a:t>
+                      </a:r>
+                    </a:p>
+                  </a:txBody>
+                  <a:tcPr>
+                    <a:solidFill>
+                      <a:srgbClr val="F7F6F2"/>
+                    </a:solidFill>
+                  </a:tcPr>
+                </a:tc>
+                <a:tc>
+                  <a:txBody>
+                    <a:bodyPr/>
+                    <a:lstStyle/>
+                    <a:p>
+                      <a:pPr algn="r"/>
+                      <a:r>
+                        <a:rPr sz="1250" b="0">
+                          <a:solidFill>
+                            <a:srgbClr val="3F4A4E"/>
+                          </a:solidFill>
+                          <a:latin typeface="Arial"/>
+                        </a:rPr>
+                        <a:t>6.1</a:t>
+                      </a:r>
+                    </a:p>
+                  </a:txBody>
+                  <a:tcPr>
+                    <a:solidFill>
+                      <a:srgbClr val="F7F6F2"/>
+                    </a:solidFill>
+                  </a:tcPr>
+                </a:tc>
+                <a:tc>
+                  <a:txBody>
+                    <a:bodyPr/>
+                    <a:lstStyle/>
+                    <a:p>
+                      <a:pPr algn="r"/>
+                      <a:r>
+                        <a:rPr sz="1250" b="0">
+                          <a:solidFill>
+                            <a:srgbClr val="3F4A4E"/>
+                          </a:solidFill>
+                          <a:latin typeface="Arial"/>
+                        </a:rPr>
+                        <a:t>4.7</a:t>
+                      </a:r>
+                    </a:p>
+                  </a:txBody>
+                  <a:tcPr>
+                    <a:solidFill>
+                      <a:srgbClr val="F7F6F2"/>
+                    </a:solidFill>
+                  </a:tcPr>
+                </a:tc>
+                <a:tc>
+                  <a:txBody>
+                    <a:bodyPr/>
+                    <a:lstStyle/>
+                    <a:p>
+                      <a:pPr algn="r"/>
+                      <a:r>
+                        <a:rPr sz="1250" b="0">
+                          <a:solidFill>
+                            <a:srgbClr val="3F4A4E"/>
+                          </a:solidFill>
+                          <a:latin typeface="Arial"/>
+                        </a:rPr>
+                        <a:t>5.7</a:t>
+                      </a:r>
+                    </a:p>
+                  </a:txBody>
+                  <a:tcPr>
+                    <a:solidFill>
+                      <a:srgbClr val="F7F6F2"/>
+                    </a:solidFill>
+                  </a:tcPr>
+                </a:tc>
+                <a:tc>
+                  <a:txBody>
+                    <a:bodyPr/>
+                    <a:lstStyle/>
+                    <a:p>
+                      <a:pPr algn="r"/>
+                      <a:r>
+                        <a:rPr sz="1250" b="0">
+                          <a:solidFill>
+                            <a:srgbClr val="3F4A4E"/>
+                          </a:solidFill>
+                          <a:latin typeface="Arial"/>
+                        </a:rPr>
+                        <a:t>5.5</a:t>
+                      </a:r>
+                    </a:p>
+                  </a:txBody>
+                  <a:tcPr>
+                    <a:solidFill>
+                      <a:srgbClr val="F7F6F2"/>
+                    </a:solidFill>
+                  </a:tcPr>
+                </a:tc>
+                <a:tc>
+                  <a:txBody>
+                    <a:bodyPr/>
+                    <a:lstStyle/>
+                    <a:p>
+                      <a:pPr algn="r"/>
+                      <a:r>
+                        <a:rPr sz="1250" b="0">
+                          <a:solidFill>
+                            <a:srgbClr val="3F4A4E"/>
+                          </a:solidFill>
+                          <a:latin typeface="Arial"/>
+                        </a:rPr>
+                        <a:t>5.5</a:t>
+                      </a:r>
+                    </a:p>
+                  </a:txBody>
+                  <a:tcPr>
+                    <a:solidFill>
+                      <a:srgbClr val="F7F6F2"/>
+                    </a:solidFill>
+                  </a:tcPr>
+                </a:tc>
+                <a:tc>
+                  <a:txBody>
+                    <a:bodyPr/>
+                    <a:lstStyle/>
+                    <a:p>
+                      <a:pPr algn="r"/>
+                      <a:r>
+                        <a:rPr sz="1250" b="0">
+                          <a:solidFill>
+                            <a:srgbClr val="3F4A4E"/>
+                          </a:solidFill>
+                          <a:latin typeface="Arial"/>
+                        </a:rPr>
+                        <a:t>5.5</a:t>
+                      </a:r>
+                    </a:p>
+                  </a:txBody>
+                  <a:tcPr>
+                    <a:solidFill>
+                      <a:srgbClr val="F7F6F2"/>
+                    </a:solidFill>
+                  </a:tcPr>
+                </a:tc>
+                <a:tc>
+                  <a:txBody>
+                    <a:bodyPr/>
+                    <a:lstStyle/>
+                    <a:p>
+                      <a:pPr algn="r"/>
+                      <a:r>
+                        <a:rPr sz="1250" b="0">
+                          <a:solidFill>
+                            <a:srgbClr val="3F4A4E"/>
+                          </a:solidFill>
+                          <a:latin typeface="Arial"/>
+                        </a:rPr>
+                        <a:t>5.5</a:t>
+                      </a:r>
+                    </a:p>
+                  </a:txBody>
+                  <a:tcPr>
+                    <a:solidFill>
+                      <a:srgbClr val="F7F6F2"/>
+                    </a:solidFill>
+                  </a:tcPr>
+                </a:tc>
+                <a:tc>
+                  <a:txBody>
+                    <a:bodyPr/>
+                    <a:lstStyle/>
+                    <a:p>
+                      <a:pPr algn="r"/>
+                      <a:r>
+                        <a:rPr sz="1250" b="0">
+                          <a:solidFill>
+                            <a:srgbClr val="3F4A4E"/>
+                          </a:solidFill>
+                          <a:latin typeface="Arial"/>
+                        </a:rPr>
+                        <a:t>5.5</a:t>
+                      </a:r>
+                    </a:p>
+                  </a:txBody>
+                  <a:tcPr>
+                    <a:solidFill>
+                      <a:srgbClr val="F7F6F2"/>
+                    </a:solidFill>
+                  </a:tcPr>
+                </a:tc>
+                <a:tc>
+                  <a:txBody>
+                    <a:bodyPr/>
+                    <a:lstStyle/>
+                    <a:p>
+                      <a:pPr algn="r"/>
+                      <a:r>
+                        <a:rPr sz="1250" b="0">
+                          <a:solidFill>
+                            <a:srgbClr val="3F4A4E"/>
+                          </a:solidFill>
+                          <a:latin typeface="Arial"/>
+                        </a:rPr>
+                        <a:t>5.5</a:t>
+                      </a:r>
+                    </a:p>
+                  </a:txBody>
+                  <a:tcPr>
+                    <a:solidFill>
+                      <a:srgbClr val="F7F6F2"/>
+                    </a:solidFill>
+                  </a:tcPr>
+                </a:tc>
+                <a:tc>
+                  <a:txBody>
+                    <a:bodyPr/>
+                    <a:lstStyle/>
+                    <a:p>
+                      <a:pPr algn="r"/>
+                      <a:r>
+                        <a:rPr sz="1250" b="0">
+                          <a:solidFill>
+                            <a:srgbClr val="3F4A4E"/>
+                          </a:solidFill>
+                          <a:latin typeface="Arial"/>
+                        </a:rPr>
+                        <a:t>5.5</a:t>
+                      </a:r>
+                    </a:p>
+                  </a:txBody>
+                  <a:tcPr>
+                    <a:solidFill>
+                      <a:srgbClr val="F7F6F2"/>
+                    </a:solidFill>
+                  </a:tcPr>
+                </a:tc>
+                <a:tc>
+                  <a:txBody>
+                    <a:bodyPr/>
+                    <a:lstStyle/>
+                    <a:p>
+                      <a:pPr algn="r"/>
+                      <a:r>
+                        <a:rPr sz="1250" b="1">
+                          <a:solidFill>
+                            <a:srgbClr val="3F4A4E"/>
+                          </a:solidFill>
+                          <a:latin typeface="Arial"/>
+                        </a:rPr>
+                        <a:t>66.0</a:t>
+                      </a:r>
+                    </a:p>
+                  </a:txBody>
+                  <a:tcPr>
+                    <a:solidFill>
+                      <a:srgbClr val="F7F6F2"/>
+                    </a:solidFill>
+                  </a:tcPr>
+                </a:tc>
+              </a:tr>
+              <a:tr h="548640">
+                <a:tc>
+                  <a:txBody>
+                    <a:bodyPr/>
+                    <a:lstStyle/>
+                    <a:p>
+                      <a:r>
+                        <a:rPr sz="1250" b="1">
+                          <a:solidFill>
+                            <a:srgbClr val="22424B"/>
+                          </a:solidFill>
+                          <a:latin typeface="Arial"/>
+                        </a:rPr>
+                        <a:t>NET OPERATING PROFIT</a:t>
+                      </a:r>
+                    </a:p>
+                  </a:txBody>
+                  <a:tcPr>
+                    <a:solidFill>
+                      <a:srgbClr val="FFFFFF"/>
+                    </a:solidFill>
+                  </a:tcPr>
+                </a:tc>
+                <a:tc>
+                  <a:txBody>
+                    <a:bodyPr/>
+                    <a:lstStyle/>
+                    <a:p>
+                      <a:pPr algn="r"/>
+                      <a:r>
+                        <a:rPr sz="1250" b="1">
+                          <a:solidFill>
+                            <a:srgbClr val="22424B"/>
+                          </a:solidFill>
+                          <a:latin typeface="Arial"/>
+                        </a:rPr>
+                        <a:t>9.1</a:t>
+                      </a:r>
+                    </a:p>
+                  </a:txBody>
+                  <a:tcPr>
+                    <a:solidFill>
+                      <a:srgbClr val="FFFFFF"/>
+                    </a:solidFill>
+                  </a:tcPr>
+                </a:tc>
+                <a:tc>
+                  <a:txBody>
+                    <a:bodyPr/>
+                    <a:lstStyle/>
+                    <a:p>
+                      <a:pPr algn="r"/>
+                      <a:r>
+                        <a:rPr sz="1250" b="1">
+                          <a:solidFill>
+                            <a:srgbClr val="22424B"/>
+                          </a:solidFill>
+                          <a:latin typeface="Arial"/>
+                        </a:rPr>
+                        <a:t>(2.6)</a:t>
+                      </a:r>
+                    </a:p>
+                  </a:txBody>
+                  <a:tcPr>
+                    <a:solidFill>
+                      <a:srgbClr val="FFFFFF"/>
+                    </a:solidFill>
+                  </a:tcPr>
+                </a:tc>
+                <a:tc>
+                  <a:txBody>
+                    <a:bodyPr/>
+                    <a:lstStyle/>
+                    <a:p>
+                      <a:pPr algn="r"/>
+                      <a:r>
+                        <a:rPr sz="1250" b="1">
+                          <a:solidFill>
+                            <a:srgbClr val="22424B"/>
+                          </a:solidFill>
+                          <a:latin typeface="Arial"/>
+                        </a:rPr>
+                        <a:t>9.1</a:t>
+                      </a:r>
+                    </a:p>
+                  </a:txBody>
+                  <a:tcPr>
+                    <a:solidFill>
+                      <a:srgbClr val="FFFFFF"/>
+                    </a:solidFill>
+                  </a:tcPr>
+                </a:tc>
+                <a:tc>
+                  <a:txBody>
+                    <a:bodyPr/>
+                    <a:lstStyle/>
+                    <a:p>
+                      <a:pPr algn="r"/>
+                      <a:r>
+                        <a:rPr sz="1250" b="1">
+                          <a:solidFill>
+                            <a:srgbClr val="22424B"/>
+                          </a:solidFill>
+                          <a:latin typeface="Arial"/>
+                        </a:rPr>
+                        <a:t>(2.6)</a:t>
+                      </a:r>
+                    </a:p>
+                  </a:txBody>
+                  <a:tcPr>
+                    <a:solidFill>
+                      <a:srgbClr val="FFFFFF"/>
+                    </a:solidFill>
+                  </a:tcPr>
+                </a:tc>
+                <a:tc>
+                  <a:txBody>
+                    <a:bodyPr/>
+                    <a:lstStyle/>
+                    <a:p>
+                      <a:pPr algn="r"/>
+                      <a:r>
+                        <a:rPr sz="1250" b="1">
+                          <a:solidFill>
+                            <a:srgbClr val="22424B"/>
+                          </a:solidFill>
+                          <a:latin typeface="Arial"/>
+                        </a:rPr>
+                        <a:t>5.8</a:t>
+                      </a:r>
+                    </a:p>
+                  </a:txBody>
+                  <a:tcPr>
+                    <a:solidFill>
+                      <a:srgbClr val="FFFFFF"/>
+                    </a:solidFill>
+                  </a:tcPr>
+                </a:tc>
+                <a:tc>
+                  <a:txBody>
+                    <a:bodyPr/>
+                    <a:lstStyle/>
+                    <a:p>
+                      <a:pPr algn="r"/>
+                      <a:r>
+                        <a:rPr sz="1250" b="1">
+                          <a:solidFill>
+                            <a:srgbClr val="22424B"/>
+                          </a:solidFill>
+                          <a:latin typeface="Arial"/>
+                        </a:rPr>
+                        <a:t>4.1</a:t>
+                      </a:r>
+                    </a:p>
+                  </a:txBody>
+                  <a:tcPr>
+                    <a:solidFill>
+                      <a:srgbClr val="FFFFFF"/>
+                    </a:solidFill>
+                  </a:tcPr>
+                </a:tc>
+                <a:tc>
+                  <a:txBody>
+                    <a:bodyPr/>
+                    <a:lstStyle/>
+                    <a:p>
+                      <a:pPr algn="r"/>
+                      <a:r>
+                        <a:rPr sz="1250" b="1">
+                          <a:solidFill>
+                            <a:srgbClr val="22424B"/>
+                          </a:solidFill>
+                          <a:latin typeface="Arial"/>
+                        </a:rPr>
+                        <a:t>4.1</a:t>
+                      </a:r>
+                    </a:p>
+                  </a:txBody>
+                  <a:tcPr>
+                    <a:solidFill>
+                      <a:srgbClr val="FFFFFF"/>
+                    </a:solidFill>
+                  </a:tcPr>
+                </a:tc>
+                <a:tc>
+                  <a:txBody>
+                    <a:bodyPr/>
+                    <a:lstStyle/>
+                    <a:p>
+                      <a:pPr algn="r"/>
+                      <a:r>
+                        <a:rPr sz="1250" b="1">
+                          <a:solidFill>
+                            <a:srgbClr val="22424B"/>
+                          </a:solidFill>
+                          <a:latin typeface="Arial"/>
+                        </a:rPr>
+                        <a:t>4.1</a:t>
+                      </a:r>
+                    </a:p>
+                  </a:txBody>
+                  <a:tcPr>
+                    <a:solidFill>
+                      <a:srgbClr val="FFFFFF"/>
+                    </a:solidFill>
+                  </a:tcPr>
+                </a:tc>
+                <a:tc>
+                  <a:txBody>
+                    <a:bodyPr/>
+                    <a:lstStyle/>
+                    <a:p>
+                      <a:pPr algn="r"/>
+                      <a:r>
+                        <a:rPr sz="1250" b="1">
+                          <a:solidFill>
+                            <a:srgbClr val="22424B"/>
+                          </a:solidFill>
+                          <a:latin typeface="Arial"/>
+                        </a:rPr>
+                        <a:t>4.1</a:t>
+                      </a:r>
+                    </a:p>
+                  </a:txBody>
+                  <a:tcPr>
+                    <a:solidFill>
+                      <a:srgbClr val="FFFFFF"/>
+                    </a:solidFill>
+                  </a:tcPr>
+                </a:tc>
+                <a:tc>
+                  <a:txBody>
+                    <a:bodyPr/>
+                    <a:lstStyle/>
+                    <a:p>
+                      <a:pPr algn="r"/>
+                      <a:r>
+                        <a:rPr sz="1250" b="1">
+                          <a:solidFill>
+                            <a:srgbClr val="22424B"/>
+                          </a:solidFill>
+                          <a:latin typeface="Arial"/>
+                        </a:rPr>
+                        <a:t>4.1</a:t>
+                      </a:r>
+                    </a:p>
+                  </a:txBody>
+                  <a:tcPr>
+                    <a:solidFill>
+                      <a:srgbClr val="FFFFFF"/>
+                    </a:solidFill>
+                  </a:tcPr>
+                </a:tc>
+                <a:tc>
+                  <a:txBody>
+                    <a:bodyPr/>
+                    <a:lstStyle/>
+                    <a:p>
+                      <a:pPr algn="r"/>
+                      <a:r>
+                        <a:rPr sz="1250" b="1">
+                          <a:solidFill>
+                            <a:srgbClr val="22424B"/>
+                          </a:solidFill>
+                          <a:latin typeface="Arial"/>
+                        </a:rPr>
+                        <a:t>4.1</a:t>
+                      </a:r>
+                    </a:p>
+                  </a:txBody>
+                  <a:tcPr>
+                    <a:solidFill>
+                      <a:srgbClr val="FFFFFF"/>
+                    </a:solidFill>
+                  </a:tcPr>
+                </a:tc>
+                <a:tc>
+                  <a:txBody>
+                    <a:bodyPr/>
+                    <a:lstStyle/>
+                    <a:p>
+                      <a:pPr algn="r"/>
+                      <a:r>
+                        <a:rPr sz="1250" b="1">
+                          <a:solidFill>
+                            <a:srgbClr val="22424B"/>
+                          </a:solidFill>
+                          <a:latin typeface="Arial"/>
+                        </a:rPr>
+                        <a:t>7.9</a:t>
+                      </a:r>
+                    </a:p>
+                  </a:txBody>
+                  <a:tcPr>
+                    <a:solidFill>
+                      <a:srgbClr val="FFFFFF"/>
+                    </a:solidFill>
+                  </a:tcPr>
+                </a:tc>
+                <a:tc>
+                  <a:txBody>
+                    <a:bodyPr/>
+                    <a:lstStyle/>
+                    <a:p>
+                      <a:pPr algn="r"/>
+                      <a:r>
+                        <a:rPr sz="1250" b="1">
+                          <a:solidFill>
+                            <a:srgbClr val="22424B"/>
+                          </a:solidFill>
+                          <a:latin typeface="Arial"/>
+                        </a:rPr>
+                        <a:t>51.4</a:t>
+                      </a:r>
+                    </a:p>
+                  </a:txBody>
+                  <a:tcPr>
+                    <a:solidFill>
+                      <a:srgbClr val="FFFFFF"/>
+                    </a:solidFill>
+                  </a:tcPr>
+                </a:tc>
+              </a:tr>
+            </a:tbl>
+          </a:graphicData>
+        </a:graphic>
+      </p:graphicFrame>
+      <p:sp>
+        <p:nvSpPr>
+          <p:cNvPr id="5" name="TextBox 4"/>
+          <p:cNvSpPr txBox="1"/>
+          <p:nvPr/>
+        </p:nvSpPr>
+        <p:spPr>
+          <a:xfrm>
+            <a:off x="950976" y="7772400"/>
+            <a:ext cx="16367759" cy="822960"/>
+          </a:xfrm>
+          <a:prstGeom prst="rect">
+            <a:avLst/>
+          </a:prstGeom>
+          <a:noFill/>
+        </p:spPr>
+        <p:txBody>
+          <a:bodyPr wrap="square">
+            <a:spAutoFit/>
+          </a:bodyPr>
+          <a:lstStyle/>
+          <a:p>
+            <a:r>
+              <a:rPr sz="1200">
                 <a:solidFill>
                   <a:srgbClr val="3F4A4E"/>
                 </a:solidFill>
                 <a:latin typeface="Arial"/>
               </a:rPr>
-              <a:t>Rendered from the Combined 12-Mo P&amp;L tab, Method_Operating_Model_2027_22.xlsx — Vessel + Little Wing, all levers in effect. FY NOP $51,360; ten of twelve months profitable (Feb/Apr dips = 3-event months at Vessel).</a:t>
+              <a:t>Vessel + Little Wing, all levers in effect. Ten of twelve months profitable — the Feb/Apr dips are Vessel’s 3-event months. Monthly shape follows the Vessel event calendar over Little Wing’s flat run-rate. Uncontrollable expenses include the 4% management fee; rent waived.</a:t>
             </a:r>
           </a:p>
         </p:txBody>

</xml_diff>